<commit_message>
Update presentation deck to match the customer-ordering web dashboard
Architecture slide now shows Customer/Restaurant/Rider apps as the three
writers into order-service (previously implied a single "restaurant"
origin). Tech stack slide adds the Web Dashboard. Live Demo slide adds
the localhost:8081 walkthrough alongside the terminal path. Order
lifecycle slide's example payload uses realistic names instead of
placeholder IDs.

Co-Authored-By: Claude Sonnet 5 <noreply@anthropic.com>
</commit_message>
<xml_diff>
--- a/presentation/Project2-Kafka-FoodDelivery-Presentation.pptx
+++ b/presentation/Project2-Kafka-FoodDelivery-Presentation.pptx
@@ -2274,7 +2274,7 @@
                 <a:ea typeface="Calibri" pitchFamily="34" charset="-122"/>
                 <a:cs typeface="Calibri" pitchFamily="34" charset="-120"/>
               </a:rPr>
-              <a:t>Our hypothetical platform splits work across four services: </a:t>
+              <a:t>Our platform splits work across four services: </a:t>
             </a:r>
             <a:pPr indent="0" marL="0">
               <a:buNone/>
@@ -3804,7 +3804,7 @@
                 <a:ea typeface="Cambria" pitchFamily="34" charset="-122"/>
                 <a:cs typeface="Cambria" pitchFamily="34" charset="-120"/>
               </a:rPr>
-              <a:t>Implementation: Architecture (After)</a:t>
+              <a:t>Implementation: Architecture</a:t>
             </a:r>
             <a:endParaRPr lang="en-US" sz="3000" dirty="0"/>
           </a:p>
@@ -3818,8 +3818,404 @@
         </p:nvSpPr>
         <p:spPr>
           <a:xfrm>
-            <a:off x="548640" y="2377440"/>
-            <a:ext cx="2377440" cy="1188720"/>
+            <a:off x="457200" y="1371600"/>
+            <a:ext cx="2331720" cy="1143000"/>
+          </a:xfrm>
+          <a:prstGeom prst="roundRect">
+            <a:avLst>
+              <a:gd name="adj" fmla="val 6400"/>
+            </a:avLst>
+          </a:prstGeom>
+          <a:solidFill>
+            <a:srgbClr val="E6F0FE"/>
+          </a:solidFill>
+          <a:ln w="16510">
+            <a:solidFill>
+              <a:srgbClr val="2F3C7E"/>
+            </a:solidFill>
+            <a:prstDash val="solid"/>
+          </a:ln>
+        </p:spPr>
+      </p:sp>
+      <p:sp>
+        <p:nvSpPr>
+          <p:cNvPr id="4" name="Text 2"/>
+          <p:cNvSpPr txBox="1"/>
+          <p:nvPr/>
+        </p:nvSpPr>
+        <p:spPr>
+          <a:xfrm>
+            <a:off x="566928" y="1481328"/>
+            <a:ext cx="2103120" cy="320040"/>
+          </a:xfrm>
+          <a:prstGeom prst="rect">
+            <a:avLst/>
+          </a:prstGeom>
+          <a:noFill/>
+          <a:ln/>
+        </p:spPr>
+        <p:txBody>
+          <a:bodyPr wrap="square" lIns="0" tIns="0" rIns="0" bIns="0" rtlCol="0" anchor="ctr"/>
+          <a:lstStyle/>
+          <a:p>
+            <a:pPr indent="0" marL="0">
+              <a:buNone/>
+            </a:pPr>
+            <a:r>
+              <a:rPr lang="en-US" sz="1300" b="1" dirty="0">
+                <a:solidFill>
+                  <a:srgbClr val="2F3C7E"/>
+                </a:solidFill>
+                <a:latin typeface="Calibri" pitchFamily="34" charset="0"/>
+                <a:ea typeface="Calibri" pitchFamily="34" charset="-122"/>
+                <a:cs typeface="Calibri" pitchFamily="34" charset="-120"/>
+              </a:rPr>
+              <a:t>Customer App</a:t>
+            </a:r>
+            <a:endParaRPr lang="en-US" sz="1300" dirty="0"/>
+          </a:p>
+        </p:txBody>
+      </p:sp>
+      <p:sp>
+        <p:nvSpPr>
+          <p:cNvPr id="5" name="Text 3"/>
+          <p:cNvSpPr txBox="1"/>
+          <p:nvPr/>
+        </p:nvSpPr>
+        <p:spPr>
+          <a:xfrm>
+            <a:off x="566928" y="1828800"/>
+            <a:ext cx="2103120" cy="594360"/>
+          </a:xfrm>
+          <a:prstGeom prst="rect">
+            <a:avLst/>
+          </a:prstGeom>
+          <a:noFill/>
+          <a:ln/>
+        </p:spPr>
+        <p:txBody>
+          <a:bodyPr wrap="square" lIns="0" tIns="0" rIns="0" bIns="0" rtlCol="0" anchor="ctr"/>
+          <a:lstStyle/>
+          <a:p>
+            <a:pPr indent="0" marL="0">
+              <a:lnSpc>
+                <a:spcPct val="115000"/>
+              </a:lnSpc>
+              <a:buNone/>
+            </a:pPr>
+            <a:r>
+              <a:rPr lang="en-US" sz="1050" dirty="0">
+                <a:solidFill>
+                  <a:srgbClr val="2F3C7E"/>
+                </a:solidFill>
+                <a:latin typeface="Calibri" pitchFamily="34" charset="0"/>
+                <a:ea typeface="Calibri" pitchFamily="34" charset="-122"/>
+                <a:cs typeface="Calibri" pitchFamily="34" charset="-120"/>
+              </a:rPr>
+              <a:t>POST /orders</a:t>
+            </a:r>
+            <a:endParaRPr lang="en-US" sz="1050" dirty="0"/>
+          </a:p>
+        </p:txBody>
+      </p:sp>
+      <p:sp>
+        <p:nvSpPr>
+          <p:cNvPr id="6" name="Shape 4"/>
+          <p:cNvSpPr/>
+          <p:nvPr/>
+        </p:nvSpPr>
+        <p:spPr>
+          <a:xfrm>
+            <a:off x="457200" y="2788920"/>
+            <a:ext cx="2331720" cy="1143000"/>
+          </a:xfrm>
+          <a:prstGeom prst="roundRect">
+            <a:avLst>
+              <a:gd name="adj" fmla="val 6400"/>
+            </a:avLst>
+          </a:prstGeom>
+          <a:solidFill>
+            <a:srgbClr val="FFF3E0"/>
+          </a:solidFill>
+          <a:ln w="16510">
+            <a:solidFill>
+              <a:srgbClr val="8A4B00"/>
+            </a:solidFill>
+            <a:prstDash val="solid"/>
+          </a:ln>
+        </p:spPr>
+      </p:sp>
+      <p:sp>
+        <p:nvSpPr>
+          <p:cNvPr id="7" name="Text 5"/>
+          <p:cNvSpPr txBox="1"/>
+          <p:nvPr/>
+        </p:nvSpPr>
+        <p:spPr>
+          <a:xfrm>
+            <a:off x="566928" y="2898648"/>
+            <a:ext cx="2103120" cy="320040"/>
+          </a:xfrm>
+          <a:prstGeom prst="rect">
+            <a:avLst/>
+          </a:prstGeom>
+          <a:noFill/>
+          <a:ln/>
+        </p:spPr>
+        <p:txBody>
+          <a:bodyPr wrap="square" lIns="0" tIns="0" rIns="0" bIns="0" rtlCol="0" anchor="ctr"/>
+          <a:lstStyle/>
+          <a:p>
+            <a:pPr indent="0" marL="0">
+              <a:buNone/>
+            </a:pPr>
+            <a:r>
+              <a:rPr lang="en-US" sz="1300" b="1" dirty="0">
+                <a:solidFill>
+                  <a:srgbClr val="8A4B00"/>
+                </a:solidFill>
+                <a:latin typeface="Calibri" pitchFamily="34" charset="0"/>
+                <a:ea typeface="Calibri" pitchFamily="34" charset="-122"/>
+                <a:cs typeface="Calibri" pitchFamily="34" charset="-120"/>
+              </a:rPr>
+              <a:t>Restaurant App</a:t>
+            </a:r>
+            <a:endParaRPr lang="en-US" sz="1300" dirty="0"/>
+          </a:p>
+        </p:txBody>
+      </p:sp>
+      <p:sp>
+        <p:nvSpPr>
+          <p:cNvPr id="8" name="Text 6"/>
+          <p:cNvSpPr txBox="1"/>
+          <p:nvPr/>
+        </p:nvSpPr>
+        <p:spPr>
+          <a:xfrm>
+            <a:off x="566928" y="3246120"/>
+            <a:ext cx="2103120" cy="594360"/>
+          </a:xfrm>
+          <a:prstGeom prst="rect">
+            <a:avLst/>
+          </a:prstGeom>
+          <a:noFill/>
+          <a:ln/>
+        </p:spPr>
+        <p:txBody>
+          <a:bodyPr wrap="square" lIns="0" tIns="0" rIns="0" bIns="0" rtlCol="0" anchor="ctr"/>
+          <a:lstStyle/>
+          <a:p>
+            <a:pPr indent="0" marL="0">
+              <a:lnSpc>
+                <a:spcPct val="115000"/>
+              </a:lnSpc>
+              <a:buNone/>
+            </a:pPr>
+            <a:r>
+              <a:rPr lang="en-US" sz="1050" dirty="0">
+                <a:solidFill>
+                  <a:srgbClr val="8A4B00"/>
+                </a:solidFill>
+                <a:latin typeface="Calibri" pitchFamily="34" charset="0"/>
+                <a:ea typeface="Calibri" pitchFamily="34" charset="-122"/>
+                <a:cs typeface="Calibri" pitchFamily="34" charset="-120"/>
+              </a:rPr>
+              <a:t>PATCH status (confirm → ready)</a:t>
+            </a:r>
+            <a:endParaRPr lang="en-US" sz="1050" dirty="0"/>
+          </a:p>
+        </p:txBody>
+      </p:sp>
+      <p:sp>
+        <p:nvSpPr>
+          <p:cNvPr id="9" name="Shape 7"/>
+          <p:cNvSpPr/>
+          <p:nvPr/>
+        </p:nvSpPr>
+        <p:spPr>
+          <a:xfrm>
+            <a:off x="457200" y="4206240"/>
+            <a:ext cx="2331720" cy="1143000"/>
+          </a:xfrm>
+          <a:prstGeom prst="roundRect">
+            <a:avLst>
+              <a:gd name="adj" fmla="val 6400"/>
+            </a:avLst>
+          </a:prstGeom>
+          <a:solidFill>
+            <a:srgbClr val="EAFAF0"/>
+          </a:solidFill>
+          <a:ln w="16510">
+            <a:solidFill>
+              <a:srgbClr val="0F7A3D"/>
+            </a:solidFill>
+            <a:prstDash val="solid"/>
+          </a:ln>
+        </p:spPr>
+      </p:sp>
+      <p:sp>
+        <p:nvSpPr>
+          <p:cNvPr id="10" name="Text 8"/>
+          <p:cNvSpPr txBox="1"/>
+          <p:nvPr/>
+        </p:nvSpPr>
+        <p:spPr>
+          <a:xfrm>
+            <a:off x="566928" y="4315968"/>
+            <a:ext cx="2103120" cy="320040"/>
+          </a:xfrm>
+          <a:prstGeom prst="rect">
+            <a:avLst/>
+          </a:prstGeom>
+          <a:noFill/>
+          <a:ln/>
+        </p:spPr>
+        <p:txBody>
+          <a:bodyPr wrap="square" lIns="0" tIns="0" rIns="0" bIns="0" rtlCol="0" anchor="ctr"/>
+          <a:lstStyle/>
+          <a:p>
+            <a:pPr indent="0" marL="0">
+              <a:buNone/>
+            </a:pPr>
+            <a:r>
+              <a:rPr lang="en-US" sz="1300" b="1" dirty="0">
+                <a:solidFill>
+                  <a:srgbClr val="0F7A3D"/>
+                </a:solidFill>
+                <a:latin typeface="Calibri" pitchFamily="34" charset="0"/>
+                <a:ea typeface="Calibri" pitchFamily="34" charset="-122"/>
+                <a:cs typeface="Calibri" pitchFamily="34" charset="-120"/>
+              </a:rPr>
+              <a:t>Rider App</a:t>
+            </a:r>
+            <a:endParaRPr lang="en-US" sz="1300" dirty="0"/>
+          </a:p>
+        </p:txBody>
+      </p:sp>
+      <p:sp>
+        <p:nvSpPr>
+          <p:cNvPr id="11" name="Text 9"/>
+          <p:cNvSpPr txBox="1"/>
+          <p:nvPr/>
+        </p:nvSpPr>
+        <p:spPr>
+          <a:xfrm>
+            <a:off x="566928" y="4663440"/>
+            <a:ext cx="2103120" cy="594360"/>
+          </a:xfrm>
+          <a:prstGeom prst="rect">
+            <a:avLst/>
+          </a:prstGeom>
+          <a:noFill/>
+          <a:ln/>
+        </p:spPr>
+        <p:txBody>
+          <a:bodyPr wrap="square" lIns="0" tIns="0" rIns="0" bIns="0" rtlCol="0" anchor="ctr"/>
+          <a:lstStyle/>
+          <a:p>
+            <a:pPr indent="0" marL="0">
+              <a:lnSpc>
+                <a:spcPct val="115000"/>
+              </a:lnSpc>
+              <a:buNone/>
+            </a:pPr>
+            <a:r>
+              <a:rPr lang="en-US" sz="1050" dirty="0">
+                <a:solidFill>
+                  <a:srgbClr val="0F7A3D"/>
+                </a:solidFill>
+                <a:latin typeface="Calibri" pitchFamily="34" charset="0"/>
+                <a:ea typeface="Calibri" pitchFamily="34" charset="-122"/>
+                <a:cs typeface="Calibri" pitchFamily="34" charset="-120"/>
+              </a:rPr>
+              <a:t>PATCH status (picked up → delivered)</a:t>
+            </a:r>
+            <a:endParaRPr lang="en-US" sz="1050" dirty="0"/>
+          </a:p>
+        </p:txBody>
+      </p:sp>
+      <p:sp>
+        <p:nvSpPr>
+          <p:cNvPr id="12" name="Shape 10"/>
+          <p:cNvSpPr/>
+          <p:nvPr/>
+        </p:nvSpPr>
+        <p:spPr>
+          <a:xfrm>
+            <a:off x="2788920" y="1943100"/>
+            <a:ext cx="1005840" cy="1394460"/>
+          </a:xfrm>
+          <a:prstGeom prst="line">
+            <a:avLst/>
+          </a:prstGeom>
+          <a:noFill/>
+          <a:ln w="20320">
+            <a:solidFill>
+              <a:srgbClr val="5B5B5B"/>
+            </a:solidFill>
+            <a:prstDash val="solid"/>
+            <a:tailEnd type="arrow"/>
+          </a:ln>
+        </p:spPr>
+      </p:sp>
+      <p:sp>
+        <p:nvSpPr>
+          <p:cNvPr id="13" name="Shape 11"/>
+          <p:cNvSpPr/>
+          <p:nvPr/>
+        </p:nvSpPr>
+        <p:spPr>
+          <a:xfrm flipV="1">
+            <a:off x="2788920" y="3337560"/>
+            <a:ext cx="1005840" cy="22860"/>
+          </a:xfrm>
+          <a:prstGeom prst="line">
+            <a:avLst/>
+          </a:prstGeom>
+          <a:noFill/>
+          <a:ln w="20320">
+            <a:solidFill>
+              <a:srgbClr val="5B5B5B"/>
+            </a:solidFill>
+            <a:prstDash val="solid"/>
+            <a:tailEnd type="arrow"/>
+          </a:ln>
+        </p:spPr>
+      </p:sp>
+      <p:sp>
+        <p:nvSpPr>
+          <p:cNvPr id="14" name="Shape 12"/>
+          <p:cNvSpPr/>
+          <p:nvPr/>
+        </p:nvSpPr>
+        <p:spPr>
+          <a:xfrm flipV="1">
+            <a:off x="2788920" y="3337560"/>
+            <a:ext cx="1005840" cy="1440180"/>
+          </a:xfrm>
+          <a:prstGeom prst="line">
+            <a:avLst/>
+          </a:prstGeom>
+          <a:noFill/>
+          <a:ln w="20320">
+            <a:solidFill>
+              <a:srgbClr val="5B5B5B"/>
+            </a:solidFill>
+            <a:prstDash val="solid"/>
+            <a:tailEnd type="arrow"/>
+          </a:ln>
+        </p:spPr>
+      </p:sp>
+      <p:sp>
+        <p:nvSpPr>
+          <p:cNvPr id="15" name="Shape 13"/>
+          <p:cNvSpPr/>
+          <p:nvPr/>
+        </p:nvSpPr>
+        <p:spPr>
+          <a:xfrm>
+            <a:off x="3794760" y="2743200"/>
+            <a:ext cx="2103120" cy="1188720"/>
           </a:xfrm>
           <a:prstGeom prst="roundRect">
             <a:avLst>
@@ -3839,30 +4235,30 @@
       </p:sp>
       <p:sp>
         <p:nvSpPr>
-          <p:cNvPr id="4" name="Text 2"/>
-          <p:cNvSpPr txBox="1"/>
-          <p:nvPr/>
-        </p:nvSpPr>
-        <p:spPr>
-          <a:xfrm>
-            <a:off x="640080" y="2487168"/>
-            <a:ext cx="2194560" cy="320040"/>
-          </a:xfrm>
-          <a:prstGeom prst="rect">
-            <a:avLst/>
-          </a:prstGeom>
-          <a:noFill/>
-          <a:ln/>
-        </p:spPr>
-        <p:txBody>
-          <a:bodyPr wrap="square" lIns="0" tIns="0" rIns="0" bIns="0" rtlCol="0" anchor="ctr"/>
-          <a:lstStyle/>
-          <a:p>
-            <a:pPr indent="0" marL="0">
-              <a:buNone/>
-            </a:pPr>
-            <a:r>
-              <a:rPr lang="en-US" sz="1350" b="1" dirty="0">
+          <p:cNvPr id="16" name="Text 14"/>
+          <p:cNvSpPr txBox="1"/>
+          <p:nvPr/>
+        </p:nvSpPr>
+        <p:spPr>
+          <a:xfrm>
+            <a:off x="3886200" y="2852928"/>
+            <a:ext cx="1920240" cy="320040"/>
+          </a:xfrm>
+          <a:prstGeom prst="rect">
+            <a:avLst/>
+          </a:prstGeom>
+          <a:noFill/>
+          <a:ln/>
+        </p:spPr>
+        <p:txBody>
+          <a:bodyPr wrap="square" lIns="0" tIns="0" rIns="0" bIns="0" rtlCol="0" anchor="ctr"/>
+          <a:lstStyle/>
+          <a:p>
+            <a:pPr indent="0" marL="0">
+              <a:buNone/>
+            </a:pPr>
+            <a:r>
+              <a:rPr lang="en-US" sz="1300" b="1" dirty="0">
                 <a:solidFill>
                   <a:srgbClr val="2F3C7E"/>
                 </a:solidFill>
@@ -3872,36 +4268,39 @@
               </a:rPr>
               <a:t>Order Service</a:t>
             </a:r>
-            <a:endParaRPr lang="en-US" sz="1350" dirty="0"/>
-          </a:p>
-        </p:txBody>
-      </p:sp>
-      <p:sp>
-        <p:nvSpPr>
-          <p:cNvPr id="5" name="Text 3"/>
-          <p:cNvSpPr txBox="1"/>
-          <p:nvPr/>
-        </p:nvSpPr>
-        <p:spPr>
-          <a:xfrm>
-            <a:off x="640080" y="2816352"/>
-            <a:ext cx="2194560" cy="685800"/>
-          </a:xfrm>
-          <a:prstGeom prst="rect">
-            <a:avLst/>
-          </a:prstGeom>
-          <a:noFill/>
-          <a:ln/>
-        </p:spPr>
-        <p:txBody>
-          <a:bodyPr wrap="square" lIns="0" tIns="0" rIns="0" bIns="0" rtlCol="0" anchor="ctr"/>
-          <a:lstStyle/>
-          <a:p>
-            <a:pPr indent="0" marL="0">
-              <a:buNone/>
-            </a:pPr>
-            <a:r>
-              <a:rPr lang="en-US" sz="1100" dirty="0">
+            <a:endParaRPr lang="en-US" sz="1300" dirty="0"/>
+          </a:p>
+        </p:txBody>
+      </p:sp>
+      <p:sp>
+        <p:nvSpPr>
+          <p:cNvPr id="17" name="Text 15"/>
+          <p:cNvSpPr txBox="1"/>
+          <p:nvPr/>
+        </p:nvSpPr>
+        <p:spPr>
+          <a:xfrm>
+            <a:off x="3886200" y="3182112"/>
+            <a:ext cx="1920240" cy="731520"/>
+          </a:xfrm>
+          <a:prstGeom prst="rect">
+            <a:avLst/>
+          </a:prstGeom>
+          <a:noFill/>
+          <a:ln/>
+        </p:spPr>
+        <p:txBody>
+          <a:bodyPr wrap="square" lIns="0" tIns="0" rIns="0" bIns="0" rtlCol="0" anchor="ctr"/>
+          <a:lstStyle/>
+          <a:p>
+            <a:pPr indent="0" marL="0">
+              <a:lnSpc>
+                <a:spcPct val="115000"/>
+              </a:lnSpc>
+              <a:buNone/>
+            </a:pPr>
+            <a:r>
+              <a:rPr lang="en-US" sz="1000" dirty="0">
                 <a:solidFill>
                   <a:srgbClr val="5B5B5B"/>
                 </a:solidFill>
@@ -3911,14 +4310,17 @@
               </a:rPr>
               <a:t>Node.js + Express</a:t>
             </a:r>
-            <a:endParaRPr lang="en-US" sz="1100" dirty="0"/>
-          </a:p>
-          <a:p>
-            <a:pPr indent="0" marL="0">
-              <a:buNone/>
-            </a:pPr>
-            <a:r>
-              <a:rPr lang="en-US" sz="1100" dirty="0">
+            <a:endParaRPr lang="en-US" sz="1000" dirty="0"/>
+          </a:p>
+          <a:p>
+            <a:pPr indent="0" marL="0">
+              <a:lnSpc>
+                <a:spcPct val="115000"/>
+              </a:lnSpc>
+              <a:buNone/>
+            </a:pPr>
+            <a:r>
+              <a:rPr lang="en-US" sz="1000" dirty="0">
                 <a:solidFill>
                   <a:srgbClr val="5B5B5B"/>
                 </a:solidFill>
@@ -3928,24 +4330,44 @@
               </a:rPr>
               <a:t>Kafka Producer</a:t>
             </a:r>
-            <a:endParaRPr lang="en-US" sz="1100" dirty="0"/>
-          </a:p>
-        </p:txBody>
-      </p:sp>
-      <p:sp>
-        <p:nvSpPr>
-          <p:cNvPr id="6" name="Shape 4"/>
+            <a:endParaRPr lang="en-US" sz="1000" dirty="0"/>
+          </a:p>
+          <a:p>
+            <a:pPr indent="0" marL="0">
+              <a:lnSpc>
+                <a:spcPct val="115000"/>
+              </a:lnSpc>
+              <a:buNone/>
+            </a:pPr>
+            <a:r>
+              <a:rPr lang="en-US" sz="1000" dirty="0">
+                <a:solidFill>
+                  <a:srgbClr val="5B5B5B"/>
+                </a:solidFill>
+                <a:latin typeface="Calibri" pitchFamily="34" charset="0"/>
+                <a:ea typeface="Calibri" pitchFamily="34" charset="-122"/>
+                <a:cs typeface="Calibri" pitchFamily="34" charset="-120"/>
+              </a:rPr>
+              <a:t>(only writer to Kafka)</a:t>
+            </a:r>
+            <a:endParaRPr lang="en-US" sz="1000" dirty="0"/>
+          </a:p>
+        </p:txBody>
+      </p:sp>
+      <p:sp>
+        <p:nvSpPr>
+          <p:cNvPr id="18" name="Shape 16"/>
           <p:cNvSpPr/>
           <p:nvPr/>
         </p:nvSpPr>
         <p:spPr>
           <a:xfrm>
-            <a:off x="3977640" y="2148840"/>
-            <a:ext cx="2834640" cy="1691640"/>
+            <a:off x="6400800" y="2514600"/>
+            <a:ext cx="2514600" cy="1645920"/>
           </a:xfrm>
           <a:prstGeom prst="roundRect">
             <a:avLst>
-              <a:gd name="adj" fmla="val 4324"/>
+              <a:gd name="adj" fmla="val 4444"/>
             </a:avLst>
           </a:prstGeom>
           <a:solidFill>
@@ -3961,30 +4383,30 @@
       </p:sp>
       <p:sp>
         <p:nvSpPr>
-          <p:cNvPr id="7" name="Text 5"/>
-          <p:cNvSpPr txBox="1"/>
-          <p:nvPr/>
-        </p:nvSpPr>
-        <p:spPr>
-          <a:xfrm>
-            <a:off x="4069080" y="2267712"/>
-            <a:ext cx="2651760" cy="320040"/>
-          </a:xfrm>
-          <a:prstGeom prst="rect">
-            <a:avLst/>
-          </a:prstGeom>
-          <a:noFill/>
-          <a:ln/>
-        </p:spPr>
-        <p:txBody>
-          <a:bodyPr wrap="square" lIns="0" tIns="0" rIns="0" bIns="0" rtlCol="0" anchor="ctr"/>
-          <a:lstStyle/>
-          <a:p>
-            <a:pPr indent="0" marL="0">
-              <a:buNone/>
-            </a:pPr>
-            <a:r>
-              <a:rPr lang="en-US" sz="1400" b="1" dirty="0">
+          <p:cNvPr id="19" name="Text 17"/>
+          <p:cNvSpPr txBox="1"/>
+          <p:nvPr/>
+        </p:nvSpPr>
+        <p:spPr>
+          <a:xfrm>
+            <a:off x="6492240" y="2633472"/>
+            <a:ext cx="2331720" cy="320040"/>
+          </a:xfrm>
+          <a:prstGeom prst="rect">
+            <a:avLst/>
+          </a:prstGeom>
+          <a:noFill/>
+          <a:ln/>
+        </p:spPr>
+        <p:txBody>
+          <a:bodyPr wrap="square" lIns="0" tIns="0" rIns="0" bIns="0" rtlCol="0" anchor="ctr"/>
+          <a:lstStyle/>
+          <a:p>
+            <a:pPr indent="0" marL="0">
+              <a:buNone/>
+            </a:pPr>
+            <a:r>
+              <a:rPr lang="en-US" sz="1350" b="1" dirty="0">
                 <a:solidFill>
                   <a:srgbClr val="8A4B00"/>
                 </a:solidFill>
@@ -3994,20 +4416,20 @@
               </a:rPr>
               <a:t>Apache Kafka</a:t>
             </a:r>
-            <a:endParaRPr lang="en-US" sz="1400" dirty="0"/>
-          </a:p>
-        </p:txBody>
-      </p:sp>
-      <p:sp>
-        <p:nvSpPr>
-          <p:cNvPr id="8" name="Text 6"/>
-          <p:cNvSpPr txBox="1"/>
-          <p:nvPr/>
-        </p:nvSpPr>
-        <p:spPr>
-          <a:xfrm>
-            <a:off x="4069080" y="2606040"/>
-            <a:ext cx="2651760" cy="1188720"/>
+            <a:endParaRPr lang="en-US" sz="1350" dirty="0"/>
+          </a:p>
+        </p:txBody>
+      </p:sp>
+      <p:sp>
+        <p:nvSpPr>
+          <p:cNvPr id="20" name="Text 18"/>
+          <p:cNvSpPr txBox="1"/>
+          <p:nvPr/>
+        </p:nvSpPr>
+        <p:spPr>
+          <a:xfrm>
+            <a:off x="6492240" y="2971800"/>
+            <a:ext cx="2331720" cy="1097280"/>
           </a:xfrm>
           <a:prstGeom prst="rect">
             <a:avLst/>
@@ -4026,7 +4448,7 @@
               <a:buNone/>
             </a:pPr>
             <a:r>
-              <a:rPr lang="en-US" sz="1050" dirty="0">
+              <a:rPr lang="en-US" sz="1000" dirty="0">
                 <a:solidFill>
                   <a:srgbClr val="6B4400"/>
                 </a:solidFill>
@@ -4036,7 +4458,7 @@
               </a:rPr>
               <a:t>topic: order.status.updated</a:t>
             </a:r>
-            <a:endParaRPr lang="en-US" sz="1050" dirty="0"/>
+            <a:endParaRPr lang="en-US" sz="1000" dirty="0"/>
           </a:p>
           <a:p>
             <a:pPr indent="0" marL="0">
@@ -4046,7 +4468,7 @@
               <a:buNone/>
             </a:pPr>
             <a:r>
-              <a:rPr lang="en-US" sz="1050" dirty="0">
+              <a:rPr lang="en-US" sz="1000" dirty="0">
                 <a:solidFill>
                   <a:srgbClr val="6B4400"/>
                 </a:solidFill>
@@ -4056,7 +4478,7 @@
               </a:rPr>
               <a:t>Events retained on disk —</a:t>
             </a:r>
-            <a:endParaRPr lang="en-US" sz="1050" dirty="0"/>
+            <a:endParaRPr lang="en-US" sz="1000" dirty="0"/>
           </a:p>
           <a:p>
             <a:pPr indent="0" marL="0">
@@ -4066,7 +4488,7 @@
               <a:buNone/>
             </a:pPr>
             <a:r>
-              <a:rPr lang="en-US" sz="1050" dirty="0">
+              <a:rPr lang="en-US" sz="1000" dirty="0">
                 <a:solidFill>
                   <a:srgbClr val="6B4400"/>
                 </a:solidFill>
@@ -4074,22 +4496,46 @@
                 <a:ea typeface="Calibri" pitchFamily="34" charset="-122"/>
                 <a:cs typeface="Calibri" pitchFamily="34" charset="-120"/>
               </a:rPr>
-              <a:t>consumers can replay after restart</a:t>
-            </a:r>
-            <a:endParaRPr lang="en-US" sz="1050" dirty="0"/>
-          </a:p>
-        </p:txBody>
-      </p:sp>
-      <p:sp>
-        <p:nvSpPr>
-          <p:cNvPr id="9" name="Shape 7"/>
+              <a:t>replay after restart</a:t>
+            </a:r>
+            <a:endParaRPr lang="en-US" sz="1000" dirty="0"/>
+          </a:p>
+        </p:txBody>
+      </p:sp>
+      <p:sp>
+        <p:nvSpPr>
+          <p:cNvPr id="21" name="Shape 19"/>
           <p:cNvSpPr/>
           <p:nvPr/>
         </p:nvSpPr>
         <p:spPr>
           <a:xfrm>
-            <a:off x="8732520" y="960120"/>
-            <a:ext cx="2880360" cy="1188720"/>
+            <a:off x="5897880" y="3337560"/>
+            <a:ext cx="502920" cy="0"/>
+          </a:xfrm>
+          <a:prstGeom prst="line">
+            <a:avLst/>
+          </a:prstGeom>
+          <a:noFill/>
+          <a:ln w="20320">
+            <a:solidFill>
+              <a:srgbClr val="5B5B5B"/>
+            </a:solidFill>
+            <a:prstDash val="solid"/>
+            <a:tailEnd type="arrow"/>
+          </a:ln>
+        </p:spPr>
+      </p:sp>
+      <p:sp>
+        <p:nvSpPr>
+          <p:cNvPr id="22" name="Shape 20"/>
+          <p:cNvSpPr/>
+          <p:nvPr/>
+        </p:nvSpPr>
+        <p:spPr>
+          <a:xfrm>
+            <a:off x="9189720" y="960120"/>
+            <a:ext cx="2514600" cy="1188720"/>
           </a:xfrm>
           <a:prstGeom prst="roundRect">
             <a:avLst>
@@ -4109,30 +4555,30 @@
       </p:sp>
       <p:sp>
         <p:nvSpPr>
-          <p:cNvPr id="10" name="Text 8"/>
-          <p:cNvSpPr txBox="1"/>
-          <p:nvPr/>
-        </p:nvSpPr>
-        <p:spPr>
-          <a:xfrm>
-            <a:off x="8851392" y="1069848"/>
-            <a:ext cx="2651760" cy="320040"/>
-          </a:xfrm>
-          <a:prstGeom prst="rect">
-            <a:avLst/>
-          </a:prstGeom>
-          <a:noFill/>
-          <a:ln/>
-        </p:spPr>
-        <p:txBody>
-          <a:bodyPr wrap="square" lIns="0" tIns="0" rIns="0" bIns="0" rtlCol="0" anchor="ctr"/>
-          <a:lstStyle/>
-          <a:p>
-            <a:pPr indent="0" marL="0">
-              <a:buNone/>
-            </a:pPr>
-            <a:r>
-              <a:rPr lang="en-US" sz="1250" b="1" dirty="0">
+          <p:cNvPr id="23" name="Text 21"/>
+          <p:cNvSpPr txBox="1"/>
+          <p:nvPr/>
+        </p:nvSpPr>
+        <p:spPr>
+          <a:xfrm>
+            <a:off x="9281160" y="1069848"/>
+            <a:ext cx="2331720" cy="502920"/>
+          </a:xfrm>
+          <a:prstGeom prst="rect">
+            <a:avLst/>
+          </a:prstGeom>
+          <a:noFill/>
+          <a:ln/>
+        </p:spPr>
+        <p:txBody>
+          <a:bodyPr wrap="square" lIns="0" tIns="0" rIns="0" bIns="0" rtlCol="0" anchor="ctr"/>
+          <a:lstStyle/>
+          <a:p>
+            <a:pPr indent="0" marL="0">
+              <a:buNone/>
+            </a:pPr>
+            <a:r>
+              <a:rPr lang="en-US" sz="1150" b="1" dirty="0">
                 <a:solidFill>
                   <a:srgbClr val="155724"/>
                 </a:solidFill>
@@ -4142,20 +4588,20 @@
               </a:rPr>
               <a:t>Customer Service</a:t>
             </a:r>
-            <a:endParaRPr lang="en-US" sz="1250" dirty="0"/>
-          </a:p>
-        </p:txBody>
-      </p:sp>
-      <p:sp>
-        <p:nvSpPr>
-          <p:cNvPr id="11" name="Text 9"/>
-          <p:cNvSpPr txBox="1"/>
-          <p:nvPr/>
-        </p:nvSpPr>
-        <p:spPr>
-          <a:xfrm>
-            <a:off x="8851392" y="1399032"/>
-            <a:ext cx="2651760" cy="640080"/>
+            <a:endParaRPr lang="en-US" sz="1150" dirty="0"/>
+          </a:p>
+        </p:txBody>
+      </p:sp>
+      <p:sp>
+        <p:nvSpPr>
+          <p:cNvPr id="24" name="Text 22"/>
+          <p:cNvSpPr txBox="1"/>
+          <p:nvPr/>
+        </p:nvSpPr>
+        <p:spPr>
+          <a:xfrm>
+            <a:off x="9281160" y="1581912"/>
+            <a:ext cx="2331720" cy="457200"/>
           </a:xfrm>
           <a:prstGeom prst="rect">
             <a:avLst/>
@@ -4174,7 +4620,7 @@
               <a:buNone/>
             </a:pPr>
             <a:r>
-              <a:rPr lang="en-US" sz="1000" dirty="0">
+              <a:rPr lang="en-US" sz="950" dirty="0">
                 <a:solidFill>
                   <a:srgbClr val="3A6B45"/>
                 </a:solidFill>
@@ -4182,42 +4628,22 @@
                 <a:ea typeface="Calibri" pitchFamily="34" charset="-122"/>
                 <a:cs typeface="Calibri" pitchFamily="34" charset="-120"/>
               </a:rPr>
-              <a:t>consumer group:</a:t>
-            </a:r>
-            <a:endParaRPr lang="en-US" sz="1000" dirty="0"/>
-          </a:p>
-          <a:p>
-            <a:pPr indent="0" marL="0">
-              <a:lnSpc>
-                <a:spcPct val="115000"/>
-              </a:lnSpc>
-              <a:buNone/>
-            </a:pPr>
-            <a:r>
-              <a:rPr lang="en-US" sz="1000" dirty="0">
-                <a:solidFill>
-                  <a:srgbClr val="3A6B45"/>
-                </a:solidFill>
-                <a:latin typeface="Calibri" pitchFamily="34" charset="0"/>
-                <a:ea typeface="Calibri" pitchFamily="34" charset="-122"/>
-                <a:cs typeface="Calibri" pitchFamily="34" charset="-120"/>
-              </a:rPr>
-              <a:t>customer-service-group</a:t>
-            </a:r>
-            <a:endParaRPr lang="en-US" sz="1000" dirty="0"/>
-          </a:p>
-        </p:txBody>
-      </p:sp>
-      <p:sp>
-        <p:nvSpPr>
-          <p:cNvPr id="12" name="Shape 10"/>
+              <a:t>updates order-tracking feed</a:t>
+            </a:r>
+            <a:endParaRPr lang="en-US" sz="950" dirty="0"/>
+          </a:p>
+        </p:txBody>
+      </p:sp>
+      <p:sp>
+        <p:nvSpPr>
+          <p:cNvPr id="25" name="Shape 23"/>
           <p:cNvSpPr/>
           <p:nvPr/>
         </p:nvSpPr>
         <p:spPr>
           <a:xfrm>
-            <a:off x="8732520" y="2423160"/>
-            <a:ext cx="2880360" cy="1188720"/>
+            <a:off x="9189720" y="2423160"/>
+            <a:ext cx="2514600" cy="1188720"/>
           </a:xfrm>
           <a:prstGeom prst="roundRect">
             <a:avLst>
@@ -4237,30 +4663,30 @@
       </p:sp>
       <p:sp>
         <p:nvSpPr>
-          <p:cNvPr id="13" name="Text 11"/>
-          <p:cNvSpPr txBox="1"/>
-          <p:nvPr/>
-        </p:nvSpPr>
-        <p:spPr>
-          <a:xfrm>
-            <a:off x="8851392" y="2532888"/>
-            <a:ext cx="2651760" cy="320040"/>
-          </a:xfrm>
-          <a:prstGeom prst="rect">
-            <a:avLst/>
-          </a:prstGeom>
-          <a:noFill/>
-          <a:ln/>
-        </p:spPr>
-        <p:txBody>
-          <a:bodyPr wrap="square" lIns="0" tIns="0" rIns="0" bIns="0" rtlCol="0" anchor="ctr"/>
-          <a:lstStyle/>
-          <a:p>
-            <a:pPr indent="0" marL="0">
-              <a:buNone/>
-            </a:pPr>
-            <a:r>
-              <a:rPr lang="en-US" sz="1250" b="1" dirty="0">
+          <p:cNvPr id="26" name="Text 24"/>
+          <p:cNvSpPr txBox="1"/>
+          <p:nvPr/>
+        </p:nvSpPr>
+        <p:spPr>
+          <a:xfrm>
+            <a:off x="9281160" y="2532888"/>
+            <a:ext cx="2331720" cy="502920"/>
+          </a:xfrm>
+          <a:prstGeom prst="rect">
+            <a:avLst/>
+          </a:prstGeom>
+          <a:noFill/>
+          <a:ln/>
+        </p:spPr>
+        <p:txBody>
+          <a:bodyPr wrap="square" lIns="0" tIns="0" rIns="0" bIns="0" rtlCol="0" anchor="ctr"/>
+          <a:lstStyle/>
+          <a:p>
+            <a:pPr indent="0" marL="0">
+              <a:buNone/>
+            </a:pPr>
+            <a:r>
+              <a:rPr lang="en-US" sz="1150" b="1" dirty="0">
                 <a:solidFill>
                   <a:srgbClr val="155724"/>
                 </a:solidFill>
@@ -4270,20 +4696,20 @@
               </a:rPr>
               <a:t>Rider Service</a:t>
             </a:r>
-            <a:endParaRPr lang="en-US" sz="1250" dirty="0"/>
-          </a:p>
-        </p:txBody>
-      </p:sp>
-      <p:sp>
-        <p:nvSpPr>
-          <p:cNvPr id="14" name="Text 12"/>
-          <p:cNvSpPr txBox="1"/>
-          <p:nvPr/>
-        </p:nvSpPr>
-        <p:spPr>
-          <a:xfrm>
-            <a:off x="8851392" y="2862072"/>
-            <a:ext cx="2651760" cy="640080"/>
+            <a:endParaRPr lang="en-US" sz="1150" dirty="0"/>
+          </a:p>
+        </p:txBody>
+      </p:sp>
+      <p:sp>
+        <p:nvSpPr>
+          <p:cNvPr id="27" name="Text 25"/>
+          <p:cNvSpPr txBox="1"/>
+          <p:nvPr/>
+        </p:nvSpPr>
+        <p:spPr>
+          <a:xfrm>
+            <a:off x="9281160" y="3044952"/>
+            <a:ext cx="2331720" cy="457200"/>
           </a:xfrm>
           <a:prstGeom prst="rect">
             <a:avLst/>
@@ -4302,7 +4728,7 @@
               <a:buNone/>
             </a:pPr>
             <a:r>
-              <a:rPr lang="en-US" sz="1000" dirty="0">
+              <a:rPr lang="en-US" sz="950" dirty="0">
                 <a:solidFill>
                   <a:srgbClr val="3A6B45"/>
                 </a:solidFill>
@@ -4310,42 +4736,22 @@
                 <a:ea typeface="Calibri" pitchFamily="34" charset="-122"/>
                 <a:cs typeface="Calibri" pitchFamily="34" charset="-120"/>
               </a:rPr>
-              <a:t>consumer group:</a:t>
-            </a:r>
-            <a:endParaRPr lang="en-US" sz="1000" dirty="0"/>
-          </a:p>
-          <a:p>
-            <a:pPr indent="0" marL="0">
-              <a:lnSpc>
-                <a:spcPct val="115000"/>
-              </a:lnSpc>
-              <a:buNone/>
-            </a:pPr>
-            <a:r>
-              <a:rPr lang="en-US" sz="1000" dirty="0">
-                <a:solidFill>
-                  <a:srgbClr val="3A6B45"/>
-                </a:solidFill>
-                <a:latin typeface="Calibri" pitchFamily="34" charset="0"/>
-                <a:ea typeface="Calibri" pitchFamily="34" charset="-122"/>
-                <a:cs typeface="Calibri" pitchFamily="34" charset="-120"/>
-              </a:rPr>
-              <a:t>rider-service-group</a:t>
-            </a:r>
-            <a:endParaRPr lang="en-US" sz="1000" dirty="0"/>
-          </a:p>
-        </p:txBody>
-      </p:sp>
-      <p:sp>
-        <p:nvSpPr>
-          <p:cNvPr id="15" name="Shape 13"/>
+              <a:t>updates pickup pool</a:t>
+            </a:r>
+            <a:endParaRPr lang="en-US" sz="950" dirty="0"/>
+          </a:p>
+        </p:txBody>
+      </p:sp>
+      <p:sp>
+        <p:nvSpPr>
+          <p:cNvPr id="28" name="Shape 26"/>
           <p:cNvSpPr/>
           <p:nvPr/>
         </p:nvSpPr>
         <p:spPr>
           <a:xfrm>
-            <a:off x="8732520" y="3886200"/>
-            <a:ext cx="2880360" cy="1188720"/>
+            <a:off x="9189720" y="3886200"/>
+            <a:ext cx="2514600" cy="1188720"/>
           </a:xfrm>
           <a:prstGeom prst="roundRect">
             <a:avLst>
@@ -4365,30 +4771,30 @@
       </p:sp>
       <p:sp>
         <p:nvSpPr>
-          <p:cNvPr id="16" name="Text 14"/>
-          <p:cNvSpPr txBox="1"/>
-          <p:nvPr/>
-        </p:nvSpPr>
-        <p:spPr>
-          <a:xfrm>
-            <a:off x="8851392" y="3995928"/>
-            <a:ext cx="2651760" cy="320040"/>
-          </a:xfrm>
-          <a:prstGeom prst="rect">
-            <a:avLst/>
-          </a:prstGeom>
-          <a:noFill/>
-          <a:ln/>
-        </p:spPr>
-        <p:txBody>
-          <a:bodyPr wrap="square" lIns="0" tIns="0" rIns="0" bIns="0" rtlCol="0" anchor="ctr"/>
-          <a:lstStyle/>
-          <a:p>
-            <a:pPr indent="0" marL="0">
-              <a:buNone/>
-            </a:pPr>
-            <a:r>
-              <a:rPr lang="en-US" sz="1250" b="1" dirty="0">
+          <p:cNvPr id="29" name="Text 27"/>
+          <p:cNvSpPr txBox="1"/>
+          <p:nvPr/>
+        </p:nvSpPr>
+        <p:spPr>
+          <a:xfrm>
+            <a:off x="9281160" y="3995928"/>
+            <a:ext cx="2331720" cy="502920"/>
+          </a:xfrm>
+          <a:prstGeom prst="rect">
+            <a:avLst/>
+          </a:prstGeom>
+          <a:noFill/>
+          <a:ln/>
+        </p:spPr>
+        <p:txBody>
+          <a:bodyPr wrap="square" lIns="0" tIns="0" rIns="0" bIns="0" rtlCol="0" anchor="ctr"/>
+          <a:lstStyle/>
+          <a:p>
+            <a:pPr indent="0" marL="0">
+              <a:buNone/>
+            </a:pPr>
+            <a:r>
+              <a:rPr lang="en-US" sz="1150" b="1" dirty="0">
                 <a:solidFill>
                   <a:srgbClr val="155724"/>
                 </a:solidFill>
@@ -4398,20 +4804,20 @@
               </a:rPr>
               <a:t>Notification Service</a:t>
             </a:r>
-            <a:endParaRPr lang="en-US" sz="1250" dirty="0"/>
-          </a:p>
-        </p:txBody>
-      </p:sp>
-      <p:sp>
-        <p:nvSpPr>
-          <p:cNvPr id="17" name="Text 15"/>
-          <p:cNvSpPr txBox="1"/>
-          <p:nvPr/>
-        </p:nvSpPr>
-        <p:spPr>
-          <a:xfrm>
-            <a:off x="8851392" y="4325112"/>
-            <a:ext cx="2651760" cy="640080"/>
+            <a:endParaRPr lang="en-US" sz="1150" dirty="0"/>
+          </a:p>
+        </p:txBody>
+      </p:sp>
+      <p:sp>
+        <p:nvSpPr>
+          <p:cNvPr id="30" name="Text 28"/>
+          <p:cNvSpPr txBox="1"/>
+          <p:nvPr/>
+        </p:nvSpPr>
+        <p:spPr>
+          <a:xfrm>
+            <a:off x="9281160" y="4507992"/>
+            <a:ext cx="2331720" cy="457200"/>
           </a:xfrm>
           <a:prstGeom prst="rect">
             <a:avLst/>
@@ -4430,7 +4836,7 @@
               <a:buNone/>
             </a:pPr>
             <a:r>
-              <a:rPr lang="en-US" sz="1000" dirty="0">
+              <a:rPr lang="en-US" sz="950" dirty="0">
                 <a:solidFill>
                   <a:srgbClr val="3A6B45"/>
                 </a:solidFill>
@@ -4438,48 +4844,28 @@
                 <a:ea typeface="Calibri" pitchFamily="34" charset="-122"/>
                 <a:cs typeface="Calibri" pitchFamily="34" charset="-120"/>
               </a:rPr>
-              <a:t>consumer group:</a:t>
-            </a:r>
-            <a:endParaRPr lang="en-US" sz="1000" dirty="0"/>
-          </a:p>
-          <a:p>
-            <a:pPr indent="0" marL="0">
-              <a:lnSpc>
-                <a:spcPct val="115000"/>
-              </a:lnSpc>
-              <a:buNone/>
-            </a:pPr>
-            <a:r>
-              <a:rPr lang="en-US" sz="1000" dirty="0">
-                <a:solidFill>
-                  <a:srgbClr val="3A6B45"/>
-                </a:solidFill>
-                <a:latin typeface="Calibri" pitchFamily="34" charset="0"/>
-                <a:ea typeface="Calibri" pitchFamily="34" charset="-122"/>
-                <a:cs typeface="Calibri" pitchFamily="34" charset="-120"/>
-              </a:rPr>
-              <a:t>notification-service-group</a:t>
-            </a:r>
-            <a:endParaRPr lang="en-US" sz="1000" dirty="0"/>
-          </a:p>
-        </p:txBody>
-      </p:sp>
-      <p:sp>
-        <p:nvSpPr>
-          <p:cNvPr id="18" name="Shape 16"/>
+              <a:t>records simulated alerts</a:t>
+            </a:r>
+            <a:endParaRPr lang="en-US" sz="950" dirty="0"/>
+          </a:p>
+        </p:txBody>
+      </p:sp>
+      <p:sp>
+        <p:nvSpPr>
+          <p:cNvPr id="31" name="Shape 29"/>
           <p:cNvSpPr/>
           <p:nvPr/>
         </p:nvSpPr>
         <p:spPr>
-          <a:xfrm>
-            <a:off x="2926080" y="2971800"/>
-            <a:ext cx="1051560" cy="9144"/>
+          <a:xfrm flipV="1">
+            <a:off x="8915400" y="3337560"/>
+            <a:ext cx="274320" cy="-1783080"/>
           </a:xfrm>
           <a:prstGeom prst="line">
             <a:avLst/>
           </a:prstGeom>
           <a:noFill/>
-          <a:ln w="25400">
+          <a:ln w="20320">
             <a:solidFill>
               <a:srgbClr val="5B5B5B"/>
             </a:solidFill>
@@ -4490,20 +4876,20 @@
       </p:sp>
       <p:sp>
         <p:nvSpPr>
-          <p:cNvPr id="19" name="Shape 17"/>
+          <p:cNvPr id="32" name="Shape 30"/>
           <p:cNvSpPr/>
           <p:nvPr/>
         </p:nvSpPr>
         <p:spPr>
           <a:xfrm flipV="1">
-            <a:off x="6812280" y="2971800"/>
-            <a:ext cx="1920240" cy="-1417320"/>
+            <a:off x="8915400" y="3337560"/>
+            <a:ext cx="274320" cy="-320040"/>
           </a:xfrm>
           <a:prstGeom prst="line">
             <a:avLst/>
           </a:prstGeom>
           <a:noFill/>
-          <a:ln w="25400">
+          <a:ln w="20320">
             <a:solidFill>
               <a:srgbClr val="5B5B5B"/>
             </a:solidFill>
@@ -4514,20 +4900,20 @@
       </p:sp>
       <p:sp>
         <p:nvSpPr>
-          <p:cNvPr id="20" name="Shape 18"/>
+          <p:cNvPr id="33" name="Shape 31"/>
           <p:cNvSpPr/>
           <p:nvPr/>
         </p:nvSpPr>
         <p:spPr>
           <a:xfrm>
-            <a:off x="6812280" y="2971800"/>
-            <a:ext cx="1920240" cy="45720"/>
+            <a:off x="8915400" y="3337560"/>
+            <a:ext cx="274320" cy="1143000"/>
           </a:xfrm>
           <a:prstGeom prst="line">
             <a:avLst/>
           </a:prstGeom>
           <a:noFill/>
-          <a:ln w="25400">
+          <a:ln w="20320">
             <a:solidFill>
               <a:srgbClr val="5B5B5B"/>
             </a:solidFill>
@@ -4538,163 +4924,18 @@
       </p:sp>
       <p:sp>
         <p:nvSpPr>
-          <p:cNvPr id="21" name="Shape 19"/>
+          <p:cNvPr id="34" name="Shape 32"/>
           <p:cNvSpPr/>
           <p:nvPr/>
         </p:nvSpPr>
         <p:spPr>
           <a:xfrm>
-            <a:off x="6812280" y="2971800"/>
-            <a:ext cx="1920240" cy="1508760"/>
-          </a:xfrm>
-          <a:prstGeom prst="line">
-            <a:avLst/>
-          </a:prstGeom>
-          <a:noFill/>
-          <a:ln w="25400">
-            <a:solidFill>
-              <a:srgbClr val="5B5B5B"/>
-            </a:solidFill>
-            <a:prstDash val="solid"/>
-            <a:tailEnd type="arrow"/>
-          </a:ln>
-        </p:spPr>
-      </p:sp>
-      <p:sp>
-        <p:nvSpPr>
-          <p:cNvPr id="22" name="Text 20"/>
-          <p:cNvSpPr txBox="1"/>
-          <p:nvPr/>
-        </p:nvSpPr>
-        <p:spPr>
-          <a:xfrm>
-            <a:off x="2971800" y="2606040"/>
-            <a:ext cx="1005840" cy="274320"/>
-          </a:xfrm>
-          <a:prstGeom prst="rect">
-            <a:avLst/>
-          </a:prstGeom>
-          <a:noFill/>
-          <a:ln/>
-        </p:spPr>
-        <p:txBody>
-          <a:bodyPr wrap="square" lIns="0" tIns="0" rIns="0" bIns="0" rtlCol="0" anchor="ctr"/>
-          <a:lstStyle/>
-          <a:p>
-            <a:pPr indent="0" marL="0">
-              <a:buNone/>
-            </a:pPr>
-            <a:r>
-              <a:rPr lang="en-US" sz="1050" dirty="0">
-                <a:solidFill>
-                  <a:srgbClr val="5B5B5B"/>
-                </a:solidFill>
-                <a:latin typeface="Calibri" pitchFamily="34" charset="0"/>
-                <a:ea typeface="Calibri" pitchFamily="34" charset="-122"/>
-                <a:cs typeface="Calibri" pitchFamily="34" charset="-120"/>
-              </a:rPr>
-              <a:t>publish</a:t>
-            </a:r>
-            <a:endParaRPr lang="en-US" sz="1050" dirty="0"/>
-          </a:p>
-        </p:txBody>
-      </p:sp>
-      <p:sp>
-        <p:nvSpPr>
-          <p:cNvPr id="23" name="Text 21"/>
-          <p:cNvSpPr txBox="1"/>
-          <p:nvPr/>
-        </p:nvSpPr>
-        <p:spPr>
-          <a:xfrm>
-            <a:off x="7178040" y="3063240"/>
-            <a:ext cx="1417320" cy="914400"/>
-          </a:xfrm>
-          <a:prstGeom prst="rect">
-            <a:avLst/>
-          </a:prstGeom>
-          <a:noFill/>
-          <a:ln/>
-        </p:spPr>
-        <p:txBody>
-          <a:bodyPr wrap="square" lIns="0" tIns="0" rIns="0" bIns="0" rtlCol="0" anchor="ctr"/>
-          <a:lstStyle/>
-          <a:p>
-            <a:pPr algn="ctr" indent="0" marL="0">
-              <a:lnSpc>
-                <a:spcPct val="110000"/>
-              </a:lnSpc>
-              <a:buNone/>
-            </a:pPr>
-            <a:r>
-              <a:rPr lang="en-US" sz="1000" dirty="0">
-                <a:solidFill>
-                  <a:srgbClr val="5B5B5B"/>
-                </a:solidFill>
-                <a:latin typeface="Calibri" pitchFamily="34" charset="0"/>
-                <a:ea typeface="Calibri" pitchFamily="34" charset="-122"/>
-                <a:cs typeface="Calibri" pitchFamily="34" charset="-120"/>
-              </a:rPr>
-              <a:t>consume</a:t>
-            </a:r>
-            <a:endParaRPr lang="en-US" sz="1000" dirty="0"/>
-          </a:p>
-          <a:p>
-            <a:pPr algn="ctr" indent="0" marL="0">
-              <a:lnSpc>
-                <a:spcPct val="110000"/>
-              </a:lnSpc>
-              <a:buNone/>
-            </a:pPr>
-            <a:r>
-              <a:rPr lang="en-US" sz="1000" dirty="0">
-                <a:solidFill>
-                  <a:srgbClr val="5B5B5B"/>
-                </a:solidFill>
-                <a:latin typeface="Calibri" pitchFamily="34" charset="0"/>
-                <a:ea typeface="Calibri" pitchFamily="34" charset="-122"/>
-                <a:cs typeface="Calibri" pitchFamily="34" charset="-120"/>
-              </a:rPr>
-              <a:t>independently,</a:t>
-            </a:r>
-            <a:endParaRPr lang="en-US" sz="1000" dirty="0"/>
-          </a:p>
-          <a:p>
-            <a:pPr algn="ctr" indent="0" marL="0">
-              <a:lnSpc>
-                <a:spcPct val="110000"/>
-              </a:lnSpc>
-              <a:buNone/>
-            </a:pPr>
-            <a:r>
-              <a:rPr lang="en-US" sz="1000" dirty="0">
-                <a:solidFill>
-                  <a:srgbClr val="5B5B5B"/>
-                </a:solidFill>
-                <a:latin typeface="Calibri" pitchFamily="34" charset="0"/>
-                <a:ea typeface="Calibri" pitchFamily="34" charset="-122"/>
-                <a:cs typeface="Calibri" pitchFamily="34" charset="-120"/>
-              </a:rPr>
-              <a:t>own pace</a:t>
-            </a:r>
-            <a:endParaRPr lang="en-US" sz="1000" dirty="0"/>
-          </a:p>
-        </p:txBody>
-      </p:sp>
-      <p:sp>
-        <p:nvSpPr>
-          <p:cNvPr id="24" name="Shape 22"/>
-          <p:cNvSpPr/>
-          <p:nvPr/>
-        </p:nvSpPr>
-        <p:spPr>
-          <a:xfrm>
-            <a:off x="548640" y="5349240"/>
-            <a:ext cx="11064240" cy="914400"/>
+            <a:off x="457200" y="5440680"/>
+            <a:ext cx="11247120" cy="868680"/>
           </a:xfrm>
           <a:prstGeom prst="roundRect">
             <a:avLst>
-              <a:gd name="adj" fmla="val 8000"/>
+              <a:gd name="adj" fmla="val 8421"/>
             </a:avLst>
           </a:prstGeom>
           <a:solidFill>
@@ -4710,30 +4951,30 @@
       </p:sp>
       <p:sp>
         <p:nvSpPr>
-          <p:cNvPr id="25" name="Text 23"/>
-          <p:cNvSpPr txBox="1"/>
-          <p:nvPr/>
-        </p:nvSpPr>
-        <p:spPr>
-          <a:xfrm>
-            <a:off x="777240" y="5486400"/>
-            <a:ext cx="10607040" cy="640080"/>
-          </a:xfrm>
-          <a:prstGeom prst="rect">
-            <a:avLst/>
-          </a:prstGeom>
-          <a:noFill/>
-          <a:ln/>
-        </p:spPr>
-        <p:txBody>
-          <a:bodyPr wrap="square" lIns="0" tIns="0" rIns="0" bIns="0" rtlCol="0" anchor="ctr"/>
-          <a:lstStyle/>
-          <a:p>
-            <a:pPr indent="0" marL="0">
-              <a:buNone/>
-            </a:pPr>
-            <a:r>
-              <a:rPr lang="en-US" sz="1300" i="1" dirty="0">
+          <p:cNvPr id="35" name="Text 33"/>
+          <p:cNvSpPr txBox="1"/>
+          <p:nvPr/>
+        </p:nvSpPr>
+        <p:spPr>
+          <a:xfrm>
+            <a:off x="685800" y="5559552"/>
+            <a:ext cx="10789920" cy="640080"/>
+          </a:xfrm>
+          <a:prstGeom prst="rect">
+            <a:avLst/>
+          </a:prstGeom>
+          <a:noFill/>
+          <a:ln/>
+        </p:spPr>
+        <p:txBody>
+          <a:bodyPr wrap="square" lIns="0" tIns="0" rIns="0" bIns="0" rtlCol="0" anchor="ctr"/>
+          <a:lstStyle/>
+          <a:p>
+            <a:pPr indent="0" marL="0">
+              <a:buNone/>
+            </a:pPr>
+            <a:r>
+              <a:rPr lang="en-US" sz="1250" i="1" dirty="0">
                 <a:solidFill>
                   <a:srgbClr val="7A1F1A"/>
                 </a:solidFill>
@@ -4741,15 +4982,15 @@
                 <a:ea typeface="Calibri" pitchFamily="34" charset="-122"/>
                 <a:cs typeface="Calibri" pitchFamily="34" charset="-120"/>
               </a:rPr>
-              <a:t>Key change: order-service never calls the other three services. It only writes to Kafka — removing the coupling that caused the pain point.</a:t>
-            </a:r>
-            <a:endParaRPr lang="en-US" sz="1300" dirty="0"/>
-          </a:p>
-        </p:txBody>
-      </p:sp>
-      <p:sp>
-        <p:nvSpPr>
-          <p:cNvPr id="26" name="Text 24"/>
+              <a:t>Key change: none of the three apps call each other. Every write goes through order-service → Kafka; every read comes from Kafka — removing the coupling that caused the pain point.</a:t>
+            </a:r>
+            <a:endParaRPr lang="en-US" sz="1250" dirty="0"/>
+          </a:p>
+        </p:txBody>
+      </p:sp>
+      <p:sp>
+        <p:nvSpPr>
+          <p:cNvPr id="36" name="Text 34"/>
           <p:cNvSpPr txBox="1"/>
           <p:nvPr/>
         </p:nvSpPr>
@@ -4788,7 +5029,7 @@
       </p:sp>
       <p:sp>
         <p:nvSpPr>
-          <p:cNvPr id="27" name="Text 25"/>
+          <p:cNvPr id="37" name="Text 35"/>
           <p:cNvSpPr txBox="1"/>
           <p:nvPr/>
         </p:nvSpPr>
@@ -5408,23 +5649,26 @@
         <p:spPr>
           <a:xfrm>
             <a:off x="548640" y="2788920"/>
-            <a:ext cx="11064240" cy="411480"/>
-          </a:xfrm>
-          <a:prstGeom prst="rect">
-            <a:avLst/>
-          </a:prstGeom>
-          <a:noFill/>
-          <a:ln/>
-        </p:spPr>
-        <p:txBody>
-          <a:bodyPr wrap="square" lIns="0" tIns="0" rIns="0" bIns="0" rtlCol="0" anchor="ctr"/>
-          <a:lstStyle/>
-          <a:p>
-            <a:pPr indent="0" marL="0">
-              <a:buNone/>
-            </a:pPr>
-            <a:r>
-              <a:rPr lang="en-US" sz="1300" i="1" dirty="0">
+            <a:ext cx="11064240" cy="502920"/>
+          </a:xfrm>
+          <a:prstGeom prst="rect">
+            <a:avLst/>
+          </a:prstGeom>
+          <a:noFill/>
+          <a:ln/>
+        </p:spPr>
+        <p:txBody>
+          <a:bodyPr wrap="square" lIns="0" tIns="0" rIns="0" bIns="0" rtlCol="0" anchor="ctr"/>
+          <a:lstStyle/>
+          <a:p>
+            <a:pPr indent="0" marL="0">
+              <a:lnSpc>
+                <a:spcPct val="120000"/>
+              </a:lnSpc>
+              <a:buNone/>
+            </a:pPr>
+            <a:r>
+              <a:rPr lang="en-US" sz="1250" i="1" dirty="0">
                 <a:solidFill>
                   <a:srgbClr val="5B5B5B"/>
                 </a:solidFill>
@@ -5432,9 +5676,9 @@
                 <a:ea typeface="Calibri" pitchFamily="34" charset="-122"/>
                 <a:cs typeface="Calibri" pitchFamily="34" charset="-120"/>
               </a:rPr>
-              <a:t>Each transition = one PATCH /orders/:id/status call on order-service → one event published to Kafka.</a:t>
-            </a:r>
-            <a:endParaRPr lang="en-US" sz="1300" dirty="0"/>
+              <a:t>PLACED comes from the customer app. CONFIRMED/PREPARING/READY_FOR_PICKUP come from the restaurant app. PICKED_UP/DELIVERED come from the rider app. Every transition still publishes one Kafka event.</a:t>
+            </a:r>
+            <a:endParaRPr lang="en-US" sz="1250" dirty="0"/>
           </a:p>
         </p:txBody>
       </p:sp>
@@ -5446,12 +5690,12 @@
         </p:nvSpPr>
         <p:spPr>
           <a:xfrm>
-            <a:off x="548640" y="3383280"/>
-            <a:ext cx="11064240" cy="2788920"/>
+            <a:off x="548640" y="3474720"/>
+            <a:ext cx="11064240" cy="2697480"/>
           </a:xfrm>
           <a:prstGeom prst="roundRect">
             <a:avLst>
-              <a:gd name="adj" fmla="val 2623"/>
+              <a:gd name="adj" fmla="val 2712"/>
             </a:avLst>
           </a:prstGeom>
           <a:solidFill>
@@ -5473,7 +5717,7 @@
         </p:nvSpPr>
         <p:spPr>
           <a:xfrm>
-            <a:off x="822960" y="3566160"/>
+            <a:off x="822960" y="3657600"/>
             <a:ext cx="7315200" cy="320040"/>
           </a:xfrm>
           <a:prstGeom prst="rect">
@@ -5506,34 +5750,57 @@
       </p:sp>
       <p:sp>
         <p:nvSpPr>
-          <p:cNvPr id="23" name="Text 21"/>
-          <p:cNvSpPr txBox="1"/>
-          <p:nvPr/>
-        </p:nvSpPr>
-        <p:spPr>
-          <a:xfrm>
-            <a:off x="822960" y="3931920"/>
-            <a:ext cx="5486400" cy="2103120"/>
-          </a:xfrm>
-          <a:prstGeom prst="rect">
-            <a:avLst/>
+          <p:cNvPr id="23" name="Shape 21"/>
+          <p:cNvSpPr/>
+          <p:nvPr/>
+        </p:nvSpPr>
+        <p:spPr>
+          <a:xfrm>
+            <a:off x="822960" y="4023360"/>
+            <a:ext cx="5486400" cy="2011680"/>
+          </a:xfrm>
+          <a:prstGeom prst="roundRect">
+            <a:avLst>
+              <a:gd name="adj" fmla="val 2273"/>
+            </a:avLst>
           </a:prstGeom>
           <a:solidFill>
             <a:srgbClr val="1E2A44"/>
           </a:solidFill>
           <a:ln/>
         </p:spPr>
-        <p:txBody>
-          <a:bodyPr wrap="square" lIns="1016" tIns="1016" rIns="1016" bIns="1016" rtlCol="0" anchor="ctr"/>
-          <a:lstStyle/>
-          <a:p>
-            <a:pPr indent="0" marL="0">
-              <a:buNone/>
-            </a:pPr>
-            <a:r>
-              <a:rPr lang="en-US" sz="1200" dirty="0">
-                <a:solidFill>
-                  <a:srgbClr val="222222"/>
+      </p:sp>
+      <p:sp>
+        <p:nvSpPr>
+          <p:cNvPr id="24" name="Text 22"/>
+          <p:cNvSpPr txBox="1"/>
+          <p:nvPr/>
+        </p:nvSpPr>
+        <p:spPr>
+          <a:xfrm>
+            <a:off x="1005840" y="4133088"/>
+            <a:ext cx="5212080" cy="1828800"/>
+          </a:xfrm>
+          <a:prstGeom prst="rect">
+            <a:avLst/>
+          </a:prstGeom>
+          <a:noFill/>
+          <a:ln/>
+        </p:spPr>
+        <p:txBody>
+          <a:bodyPr wrap="square" lIns="0" tIns="0" rIns="0" bIns="0" rtlCol="0" anchor="ctr"/>
+          <a:lstStyle/>
+          <a:p>
+            <a:pPr indent="0" marL="0">
+              <a:lnSpc>
+                <a:spcPct val="115000"/>
+              </a:lnSpc>
+              <a:buNone/>
+            </a:pPr>
+            <a:r>
+              <a:rPr lang="en-US" sz="1150" dirty="0">
+                <a:solidFill>
+                  <a:srgbClr val="9FB3E8"/>
                 </a:solidFill>
                 <a:latin typeface="Courier New" pitchFamily="34" charset="0"/>
                 <a:ea typeface="Courier New" pitchFamily="34" charset="-122"/>
@@ -5543,12 +5810,15 @@
 </a:t>
             </a:r>
             <a:pPr indent="0" marL="0">
-              <a:buNone/>
-            </a:pPr>
-            <a:r>
-              <a:rPr lang="en-US" sz="1200" dirty="0">
-                <a:solidFill>
-                  <a:srgbClr val="222222"/>
+              <a:lnSpc>
+                <a:spcPct val="115000"/>
+              </a:lnSpc>
+              <a:buNone/>
+            </a:pPr>
+            <a:r>
+              <a:rPr lang="en-US" sz="1150" dirty="0">
+                <a:solidFill>
+                  <a:srgbClr val="E8ECFA"/>
                 </a:solidFill>
                 <a:latin typeface="Courier New" pitchFamily="34" charset="0"/>
                 <a:ea typeface="Courier New" pitchFamily="34" charset="-122"/>
@@ -5558,12 +5828,15 @@
 </a:t>
             </a:r>
             <a:pPr indent="0" marL="0">
-              <a:buNone/>
-            </a:pPr>
-            <a:r>
-              <a:rPr lang="en-US" sz="1200" dirty="0">
-                <a:solidFill>
-                  <a:srgbClr val="222222"/>
+              <a:lnSpc>
+                <a:spcPct val="115000"/>
+              </a:lnSpc>
+              <a:buNone/>
+            </a:pPr>
+            <a:r>
+              <a:rPr lang="en-US" sz="1150" dirty="0">
+                <a:solidFill>
+                  <a:srgbClr val="E8ECFA"/>
                 </a:solidFill>
                 <a:latin typeface="Courier New" pitchFamily="34" charset="0"/>
                 <a:ea typeface="Courier New" pitchFamily="34" charset="-122"/>
@@ -5573,42 +5846,51 @@
 </a:t>
             </a:r>
             <a:pPr indent="0" marL="0">
-              <a:buNone/>
-            </a:pPr>
-            <a:r>
-              <a:rPr lang="en-US" sz="1200" dirty="0">
-                <a:solidFill>
-                  <a:srgbClr val="222222"/>
+              <a:lnSpc>
+                <a:spcPct val="115000"/>
+              </a:lnSpc>
+              <a:buNone/>
+            </a:pPr>
+            <a:r>
+              <a:rPr lang="en-US" sz="1150" dirty="0">
+                <a:solidFill>
+                  <a:srgbClr val="E8ECFA"/>
                 </a:solidFill>
                 <a:latin typeface="Courier New" pitchFamily="34" charset="0"/>
                 <a:ea typeface="Courier New" pitchFamily="34" charset="-122"/>
                 <a:cs typeface="Courier New" pitchFamily="34" charset="-120"/>
               </a:rPr>
-              <a:t>  "customerId": "cust-1",
+              <a:t>  "customerId": "Aye Chan",
 </a:t>
             </a:r>
             <a:pPr indent="0" marL="0">
-              <a:buNone/>
-            </a:pPr>
-            <a:r>
-              <a:rPr lang="en-US" sz="1200" dirty="0">
-                <a:solidFill>
-                  <a:srgbClr val="222222"/>
+              <a:lnSpc>
+                <a:spcPct val="115000"/>
+              </a:lnSpc>
+              <a:buNone/>
+            </a:pPr>
+            <a:r>
+              <a:rPr lang="en-US" sz="1150" dirty="0">
+                <a:solidFill>
+                  <a:srgbClr val="E8ECFA"/>
                 </a:solidFill>
                 <a:latin typeface="Courier New" pitchFamily="34" charset="0"/>
                 <a:ea typeface="Courier New" pitchFamily="34" charset="-122"/>
                 <a:cs typeface="Courier New" pitchFamily="34" charset="-120"/>
               </a:rPr>
-              <a:t>  "riderId": "rider-9",
+              <a:t>  "riderId": "Ren-12",
 </a:t>
             </a:r>
             <a:pPr indent="0" marL="0">
-              <a:buNone/>
-            </a:pPr>
-            <a:r>
-              <a:rPr lang="en-US" sz="1200" b="1" dirty="0">
-                <a:solidFill>
-                  <a:srgbClr val="F96167"/>
+              <a:lnSpc>
+                <a:spcPct val="115000"/>
+              </a:lnSpc>
+              <a:buNone/>
+            </a:pPr>
+            <a:r>
+              <a:rPr lang="en-US" sz="1150" b="1" dirty="0">
+                <a:solidFill>
+                  <a:srgbClr val="F9E795"/>
                 </a:solidFill>
                 <a:latin typeface="Courier New" pitchFamily="34" charset="0"/>
                 <a:ea typeface="Courier New" pitchFamily="34" charset="-122"/>
@@ -5618,12 +5900,15 @@
 </a:t>
             </a:r>
             <a:pPr indent="0" marL="0">
-              <a:buNone/>
-            </a:pPr>
-            <a:r>
-              <a:rPr lang="en-US" sz="1200" dirty="0">
-                <a:solidFill>
-                  <a:srgbClr val="222222"/>
+              <a:lnSpc>
+                <a:spcPct val="115000"/>
+              </a:lnSpc>
+              <a:buNone/>
+            </a:pPr>
+            <a:r>
+              <a:rPr lang="en-US" sz="1150" dirty="0">
+                <a:solidFill>
+                  <a:srgbClr val="E8ECFA"/>
                 </a:solidFill>
                 <a:latin typeface="Courier New" pitchFamily="34" charset="0"/>
                 <a:ea typeface="Courier New" pitchFamily="34" charset="-122"/>
@@ -5633,12 +5918,15 @@
 </a:t>
             </a:r>
             <a:pPr indent="0" marL="0">
-              <a:buNone/>
-            </a:pPr>
-            <a:r>
-              <a:rPr lang="en-US" sz="1200" dirty="0">
-                <a:solidFill>
-                  <a:srgbClr val="222222"/>
+              <a:lnSpc>
+                <a:spcPct val="115000"/>
+              </a:lnSpc>
+              <a:buNone/>
+            </a:pPr>
+            <a:r>
+              <a:rPr lang="en-US" sz="1150" dirty="0">
+                <a:solidFill>
+                  <a:srgbClr val="9FB3E8"/>
                 </a:solidFill>
                 <a:latin typeface="Courier New" pitchFamily="34" charset="0"/>
                 <a:ea typeface="Courier New" pitchFamily="34" charset="-122"/>
@@ -5646,31 +5934,9 @@
               </a:rPr>
               <a:t>}</a:t>
             </a:r>
-            <a:endParaRPr lang="en-US" sz="1200" dirty="0"/>
-          </a:p>
-        </p:txBody>
-      </p:sp>
-      <p:sp>
-        <p:nvSpPr>
-          <p:cNvPr id="24" name="Shape 22"/>
-          <p:cNvSpPr/>
-          <p:nvPr/>
-        </p:nvSpPr>
-        <p:spPr>
-          <a:xfrm>
-            <a:off x="822960" y="3931920"/>
-            <a:ext cx="5486400" cy="2103120"/>
-          </a:xfrm>
-          <a:prstGeom prst="roundRect">
-            <a:avLst>
-              <a:gd name="adj" fmla="val 2174"/>
-            </a:avLst>
-          </a:prstGeom>
-          <a:solidFill>
-            <a:srgbClr val="1E2A44"/>
-          </a:solidFill>
-          <a:ln/>
-        </p:spPr>
+            <a:endParaRPr lang="en-US" sz="1150" dirty="0"/>
+          </a:p>
+        </p:txBody>
       </p:sp>
       <p:sp>
         <p:nvSpPr>
@@ -5680,163 +5946,34 @@
         </p:nvSpPr>
         <p:spPr>
           <a:xfrm>
-            <a:off x="1005840" y="4041648"/>
-            <a:ext cx="5212080" cy="1920240"/>
-          </a:xfrm>
-          <a:prstGeom prst="rect">
-            <a:avLst/>
-          </a:prstGeom>
-          <a:noFill/>
-          <a:ln/>
-        </p:spPr>
-        <p:txBody>
-          <a:bodyPr wrap="square" lIns="0" tIns="0" rIns="0" bIns="0" rtlCol="0" anchor="ctr"/>
-          <a:lstStyle/>
-          <a:p>
-            <a:pPr indent="0" marL="0">
-              <a:lnSpc>
-                <a:spcPct val="115000"/>
-              </a:lnSpc>
-              <a:buNone/>
-            </a:pPr>
-            <a:r>
-              <a:rPr lang="en-US" sz="1200" dirty="0">
-                <a:solidFill>
-                  <a:srgbClr val="9FB3E8"/>
-                </a:solidFill>
-                <a:latin typeface="Courier New" pitchFamily="34" charset="0"/>
-                <a:ea typeface="Courier New" pitchFamily="34" charset="-122"/>
-                <a:cs typeface="Courier New" pitchFamily="34" charset="-120"/>
-              </a:rPr>
-              <a:t>{
-</a:t>
-            </a:r>
-            <a:pPr indent="0" marL="0">
-              <a:lnSpc>
-                <a:spcPct val="115000"/>
-              </a:lnSpc>
-              <a:buNone/>
-            </a:pPr>
-            <a:r>
-              <a:rPr lang="en-US" sz="1200" dirty="0">
-                <a:solidFill>
-                  <a:srgbClr val="E8ECFA"/>
-                </a:solidFill>
-                <a:latin typeface="Courier New" pitchFamily="34" charset="0"/>
-                <a:ea typeface="Courier New" pitchFamily="34" charset="-122"/>
-                <a:cs typeface="Courier New" pitchFamily="34" charset="-120"/>
-              </a:rPr>
-              <a:t>  "orderId": 1,
-</a:t>
-            </a:r>
-            <a:pPr indent="0" marL="0">
-              <a:lnSpc>
-                <a:spcPct val="115000"/>
-              </a:lnSpc>
-              <a:buNone/>
-            </a:pPr>
-            <a:r>
-              <a:rPr lang="en-US" sz="1200" dirty="0">
-                <a:solidFill>
-                  <a:srgbClr val="E8ECFA"/>
-                </a:solidFill>
-                <a:latin typeface="Courier New" pitchFamily="34" charset="0"/>
-                <a:ea typeface="Courier New" pitchFamily="34" charset="-122"/>
-                <a:cs typeface="Courier New" pitchFamily="34" charset="-120"/>
-              </a:rPr>
-              <a:t>  "restaurantId": "resto-1",
-</a:t>
-            </a:r>
-            <a:pPr indent="0" marL="0">
-              <a:lnSpc>
-                <a:spcPct val="115000"/>
-              </a:lnSpc>
-              <a:buNone/>
-            </a:pPr>
-            <a:r>
-              <a:rPr lang="en-US" sz="1200" dirty="0">
-                <a:solidFill>
-                  <a:srgbClr val="E8ECFA"/>
-                </a:solidFill>
-                <a:latin typeface="Courier New" pitchFamily="34" charset="0"/>
-                <a:ea typeface="Courier New" pitchFamily="34" charset="-122"/>
-                <a:cs typeface="Courier New" pitchFamily="34" charset="-120"/>
-              </a:rPr>
-              <a:t>  "customerId": "cust-1",
-</a:t>
-            </a:r>
-            <a:pPr indent="0" marL="0">
-              <a:lnSpc>
-                <a:spcPct val="115000"/>
-              </a:lnSpc>
-              <a:buNone/>
-            </a:pPr>
-            <a:r>
-              <a:rPr lang="en-US" sz="1200" dirty="0">
-                <a:solidFill>
-                  <a:srgbClr val="E8ECFA"/>
-                </a:solidFill>
-                <a:latin typeface="Courier New" pitchFamily="34" charset="0"/>
-                <a:ea typeface="Courier New" pitchFamily="34" charset="-122"/>
-                <a:cs typeface="Courier New" pitchFamily="34" charset="-120"/>
-              </a:rPr>
-              <a:t>  "riderId": "rider-9",
-</a:t>
-            </a:r>
-            <a:pPr indent="0" marL="0">
-              <a:lnSpc>
-                <a:spcPct val="115000"/>
-              </a:lnSpc>
-              <a:buNone/>
-            </a:pPr>
-            <a:r>
-              <a:rPr lang="en-US" sz="1200" b="1" dirty="0">
-                <a:solidFill>
-                  <a:srgbClr val="F9E795"/>
-                </a:solidFill>
-                <a:latin typeface="Courier New" pitchFamily="34" charset="0"/>
-                <a:ea typeface="Courier New" pitchFamily="34" charset="-122"/>
-                <a:cs typeface="Courier New" pitchFamily="34" charset="-120"/>
-              </a:rPr>
-              <a:t>  "status": "READY_FOR_PICKUP",
-</a:t>
-            </a:r>
-            <a:pPr indent="0" marL="0">
-              <a:lnSpc>
-                <a:spcPct val="115000"/>
-              </a:lnSpc>
-              <a:buNone/>
-            </a:pPr>
-            <a:r>
-              <a:rPr lang="en-US" sz="1200" dirty="0">
-                <a:solidFill>
-                  <a:srgbClr val="E8ECFA"/>
-                </a:solidFill>
-                <a:latin typeface="Courier New" pitchFamily="34" charset="0"/>
-                <a:ea typeface="Courier New" pitchFamily="34" charset="-122"/>
-                <a:cs typeface="Courier New" pitchFamily="34" charset="-120"/>
-              </a:rPr>
-              <a:t>  "updatedAt": "2026-09-22T14:37:03.6Z"
-</a:t>
-            </a:r>
-            <a:pPr indent="0" marL="0">
-              <a:lnSpc>
-                <a:spcPct val="115000"/>
-              </a:lnSpc>
-              <a:buNone/>
-            </a:pPr>
-            <a:r>
-              <a:rPr lang="en-US" sz="1200" dirty="0">
-                <a:solidFill>
-                  <a:srgbClr val="9FB3E8"/>
-                </a:solidFill>
-                <a:latin typeface="Courier New" pitchFamily="34" charset="0"/>
-                <a:ea typeface="Courier New" pitchFamily="34" charset="-122"/>
-                <a:cs typeface="Courier New" pitchFamily="34" charset="-120"/>
-              </a:rPr>
-              <a:t>}</a:t>
-            </a:r>
-            <a:endParaRPr lang="en-US" sz="1200" dirty="0"/>
+            <a:off x="6492240" y="3657600"/>
+            <a:ext cx="4846320" cy="320040"/>
+          </a:xfrm>
+          <a:prstGeom prst="rect">
+            <a:avLst/>
+          </a:prstGeom>
+          <a:noFill/>
+          <a:ln/>
+        </p:spPr>
+        <p:txBody>
+          <a:bodyPr wrap="square" lIns="0" tIns="0" rIns="0" bIns="0" rtlCol="0" anchor="ctr"/>
+          <a:lstStyle/>
+          <a:p>
+            <a:pPr indent="0" marL="0">
+              <a:buNone/>
+            </a:pPr>
+            <a:r>
+              <a:rPr lang="en-US" sz="1350" b="1" dirty="0">
+                <a:solidFill>
+                  <a:srgbClr val="2F3C7E"/>
+                </a:solidFill>
+                <a:latin typeface="Calibri" pitchFamily="34" charset="0"/>
+                <a:ea typeface="Calibri" pitchFamily="34" charset="-122"/>
+                <a:cs typeface="Calibri" pitchFamily="34" charset="-120"/>
+              </a:rPr>
+              <a:t>Why this matters</a:t>
+            </a:r>
+            <a:endParaRPr lang="en-US" sz="1350" dirty="0"/>
           </a:p>
         </p:txBody>
       </p:sp>
@@ -5848,47 +5985,8 @@
         </p:nvSpPr>
         <p:spPr>
           <a:xfrm>
-            <a:off x="6492240" y="3566160"/>
-            <a:ext cx="4846320" cy="320040"/>
-          </a:xfrm>
-          <a:prstGeom prst="rect">
-            <a:avLst/>
-          </a:prstGeom>
-          <a:noFill/>
-          <a:ln/>
-        </p:spPr>
-        <p:txBody>
-          <a:bodyPr wrap="square" lIns="0" tIns="0" rIns="0" bIns="0" rtlCol="0" anchor="ctr"/>
-          <a:lstStyle/>
-          <a:p>
-            <a:pPr indent="0" marL="0">
-              <a:buNone/>
-            </a:pPr>
-            <a:r>
-              <a:rPr lang="en-US" sz="1350" b="1" dirty="0">
-                <a:solidFill>
-                  <a:srgbClr val="2F3C7E"/>
-                </a:solidFill>
-                <a:latin typeface="Calibri" pitchFamily="34" charset="0"/>
-                <a:ea typeface="Calibri" pitchFamily="34" charset="-122"/>
-                <a:cs typeface="Calibri" pitchFamily="34" charset="-120"/>
-              </a:rPr>
-              <a:t>Why this matters</a:t>
-            </a:r>
-            <a:endParaRPr lang="en-US" sz="1350" dirty="0"/>
-          </a:p>
-        </p:txBody>
-      </p:sp>
-      <p:sp>
-        <p:nvSpPr>
-          <p:cNvPr id="27" name="Text 25"/>
-          <p:cNvSpPr txBox="1"/>
-          <p:nvPr/>
-        </p:nvSpPr>
-        <p:spPr>
-          <a:xfrm>
-            <a:off x="6492240" y="3931920"/>
-            <a:ext cx="4846320" cy="2011680"/>
+            <a:off x="6492240" y="4023360"/>
+            <a:ext cx="4846320" cy="1828800"/>
           </a:xfrm>
           <a:prstGeom prst="rect">
             <a:avLst/>
@@ -5907,7 +6005,7 @@
               <a:buNone/>
             </a:pPr>
             <a:r>
-              <a:rPr lang="en-US" sz="1300" dirty="0">
+              <a:rPr lang="en-US" sz="1250" dirty="0">
                 <a:solidFill>
                   <a:srgbClr val="222222"/>
                 </a:solidFill>
@@ -5917,13 +6015,13 @@
               </a:rPr>
               <a:t>customer-service, rider-service, and notification-service all read this same event independently. None of them ask order-service for it — they just consume the topic, which means a slow or restarting consumer never blocks the others.</a:t>
             </a:r>
-            <a:endParaRPr lang="en-US" sz="1300" dirty="0"/>
-          </a:p>
-        </p:txBody>
-      </p:sp>
-      <p:sp>
-        <p:nvSpPr>
-          <p:cNvPr id="28" name="Text 26"/>
+            <a:endParaRPr lang="en-US" sz="1250" dirty="0"/>
+          </a:p>
+        </p:txBody>
+      </p:sp>
+      <p:sp>
+        <p:nvSpPr>
+          <p:cNvPr id="27" name="Text 25"/>
           <p:cNvSpPr txBox="1"/>
           <p:nvPr/>
         </p:nvSpPr>
@@ -5962,7 +6060,7 @@
       </p:sp>
       <p:sp>
         <p:nvSpPr>
-          <p:cNvPr id="29" name="Text 27"/>
+          <p:cNvPr id="28" name="Text 26"/>
           <p:cNvSpPr txBox="1"/>
           <p:nvPr/>
         </p:nvSpPr>
@@ -6078,12 +6176,12 @@
         </p:nvSpPr>
         <p:spPr>
           <a:xfrm>
-            <a:off x="548640" y="1417320"/>
-            <a:ext cx="5303520" cy="1188720"/>
+            <a:off x="548640" y="1188720"/>
+            <a:ext cx="5303520" cy="932688"/>
           </a:xfrm>
           <a:prstGeom prst="roundRect">
             <a:avLst>
-              <a:gd name="adj" fmla="val 6154"/>
+              <a:gd name="adj" fmla="val 7843"/>
             </a:avLst>
           </a:prstGeom>
           <a:solidFill>
@@ -6105,8 +6203,8 @@
         </p:nvSpPr>
         <p:spPr>
           <a:xfrm>
-            <a:off x="777240" y="1691640"/>
-            <a:ext cx="640080" cy="640080"/>
+            <a:off x="713232" y="1362456"/>
+            <a:ext cx="530352" cy="530352"/>
           </a:xfrm>
           <a:prstGeom prst="ellipse">
             <a:avLst/>
@@ -6125,8 +6223,8 @@
         </p:nvSpPr>
         <p:spPr>
           <a:xfrm>
-            <a:off x="777240" y="1691640"/>
-            <a:ext cx="640080" cy="640080"/>
+            <a:off x="713232" y="1362456"/>
+            <a:ext cx="530352" cy="530352"/>
           </a:xfrm>
           <a:prstGeom prst="rect">
             <a:avLst/>
@@ -6142,7 +6240,7 @@
               <a:buNone/>
             </a:pPr>
             <a:r>
-              <a:rPr lang="en-US" sz="1600" b="1" dirty="0">
+              <a:rPr lang="en-US" sz="1300" b="1" dirty="0">
                 <a:solidFill>
                   <a:srgbClr val="FFFFFF"/>
                 </a:solidFill>
@@ -6152,7 +6250,7 @@
               </a:rPr>
               <a:t>1</a:t>
             </a:r>
-            <a:endParaRPr lang="en-US" sz="1600" dirty="0"/>
+            <a:endParaRPr lang="en-US" sz="1300" dirty="0"/>
           </a:p>
         </p:txBody>
       </p:sp>
@@ -6164,24 +6262,24 @@
         </p:nvSpPr>
         <p:spPr>
           <a:xfrm>
-            <a:off x="1600200" y="1554480"/>
-            <a:ext cx="4023360" cy="320040"/>
-          </a:xfrm>
-          <a:prstGeom prst="rect">
-            <a:avLst/>
-          </a:prstGeom>
-          <a:noFill/>
-          <a:ln/>
-        </p:spPr>
-        <p:txBody>
-          <a:bodyPr wrap="square" lIns="0" tIns="0" rIns="0" bIns="0" rtlCol="0" anchor="ctr"/>
-          <a:lstStyle/>
-          <a:p>
-            <a:pPr indent="0" marL="0">
-              <a:buNone/>
-            </a:pPr>
-            <a:r>
-              <a:rPr lang="en-US" sz="1400" b="1" dirty="0">
+            <a:off x="1417320" y="1261872"/>
+            <a:ext cx="4251960" cy="274320"/>
+          </a:xfrm>
+          <a:prstGeom prst="rect">
+            <a:avLst/>
+          </a:prstGeom>
+          <a:noFill/>
+          <a:ln/>
+        </p:spPr>
+        <p:txBody>
+          <a:bodyPr wrap="square" lIns="0" tIns="0" rIns="0" bIns="0" rtlCol="0" anchor="ctr"/>
+          <a:lstStyle/>
+          <a:p>
+            <a:pPr indent="0" marL="0">
+              <a:buNone/>
+            </a:pPr>
+            <a:r>
+              <a:rPr lang="en-US" sz="1250" b="1" dirty="0">
                 <a:solidFill>
                   <a:srgbClr val="2F3C7E"/>
                 </a:solidFill>
@@ -6191,7 +6289,7 @@
               </a:rPr>
               <a:t>Apache Kafka</a:t>
             </a:r>
-            <a:endParaRPr lang="en-US" sz="1400" dirty="0"/>
+            <a:endParaRPr lang="en-US" sz="1250" dirty="0"/>
           </a:p>
         </p:txBody>
       </p:sp>
@@ -6203,8 +6301,8 @@
         </p:nvSpPr>
         <p:spPr>
           <a:xfrm>
-            <a:off x="1600200" y="1892808"/>
-            <a:ext cx="4114800" cy="640080"/>
+            <a:off x="1417320" y="1554480"/>
+            <a:ext cx="4297680" cy="530352"/>
           </a:xfrm>
           <a:prstGeom prst="rect">
             <a:avLst/>
@@ -6218,12 +6316,12 @@
           <a:p>
             <a:pPr indent="0" marL="0">
               <a:lnSpc>
-                <a:spcPct val="115000"/>
+                <a:spcPct val="108000"/>
               </a:lnSpc>
               <a:buNone/>
             </a:pPr>
             <a:r>
-              <a:rPr lang="en-US" sz="1100" dirty="0">
+              <a:rPr lang="en-US" sz="980" dirty="0">
                 <a:solidFill>
                   <a:srgbClr val="5B5B5B"/>
                 </a:solidFill>
@@ -6233,7 +6331,7 @@
               </a:rPr>
               <a:t>Event-streaming platform — single-node KRaft mode, no Zookeeper.</a:t>
             </a:r>
-            <a:endParaRPr lang="en-US" sz="1100" dirty="0"/>
+            <a:endParaRPr lang="en-US" sz="980" dirty="0"/>
           </a:p>
         </p:txBody>
       </p:sp>
@@ -6245,12 +6343,12 @@
         </p:nvSpPr>
         <p:spPr>
           <a:xfrm>
-            <a:off x="6217920" y="1417320"/>
-            <a:ext cx="5303520" cy="1188720"/>
+            <a:off x="6217920" y="1188720"/>
+            <a:ext cx="5303520" cy="932688"/>
           </a:xfrm>
           <a:prstGeom prst="roundRect">
             <a:avLst>
-              <a:gd name="adj" fmla="val 6154"/>
+              <a:gd name="adj" fmla="val 7843"/>
             </a:avLst>
           </a:prstGeom>
           <a:solidFill>
@@ -6272,8 +6370,8 @@
         </p:nvSpPr>
         <p:spPr>
           <a:xfrm>
-            <a:off x="6446520" y="1691640"/>
-            <a:ext cx="640080" cy="640080"/>
+            <a:off x="6382512" y="1362456"/>
+            <a:ext cx="530352" cy="530352"/>
           </a:xfrm>
           <a:prstGeom prst="ellipse">
             <a:avLst/>
@@ -6292,8 +6390,8 @@
         </p:nvSpPr>
         <p:spPr>
           <a:xfrm>
-            <a:off x="6446520" y="1691640"/>
-            <a:ext cx="640080" cy="640080"/>
+            <a:off x="6382512" y="1362456"/>
+            <a:ext cx="530352" cy="530352"/>
           </a:xfrm>
           <a:prstGeom prst="rect">
             <a:avLst/>
@@ -6309,7 +6407,7 @@
               <a:buNone/>
             </a:pPr>
             <a:r>
-              <a:rPr lang="en-US" sz="1600" b="1" dirty="0">
+              <a:rPr lang="en-US" sz="1300" b="1" dirty="0">
                 <a:solidFill>
                   <a:srgbClr val="FFFFFF"/>
                 </a:solidFill>
@@ -6319,7 +6417,7 @@
               </a:rPr>
               <a:t>2</a:t>
             </a:r>
-            <a:endParaRPr lang="en-US" sz="1600" dirty="0"/>
+            <a:endParaRPr lang="en-US" sz="1300" dirty="0"/>
           </a:p>
         </p:txBody>
       </p:sp>
@@ -6331,24 +6429,24 @@
         </p:nvSpPr>
         <p:spPr>
           <a:xfrm>
-            <a:off x="7269480" y="1554480"/>
-            <a:ext cx="4023360" cy="320040"/>
-          </a:xfrm>
-          <a:prstGeom prst="rect">
-            <a:avLst/>
-          </a:prstGeom>
-          <a:noFill/>
-          <a:ln/>
-        </p:spPr>
-        <p:txBody>
-          <a:bodyPr wrap="square" lIns="0" tIns="0" rIns="0" bIns="0" rtlCol="0" anchor="ctr"/>
-          <a:lstStyle/>
-          <a:p>
-            <a:pPr indent="0" marL="0">
-              <a:buNone/>
-            </a:pPr>
-            <a:r>
-              <a:rPr lang="en-US" sz="1400" b="1" dirty="0">
+            <a:off x="7086600" y="1261872"/>
+            <a:ext cx="4251960" cy="274320"/>
+          </a:xfrm>
+          <a:prstGeom prst="rect">
+            <a:avLst/>
+          </a:prstGeom>
+          <a:noFill/>
+          <a:ln/>
+        </p:spPr>
+        <p:txBody>
+          <a:bodyPr wrap="square" lIns="0" tIns="0" rIns="0" bIns="0" rtlCol="0" anchor="ctr"/>
+          <a:lstStyle/>
+          <a:p>
+            <a:pPr indent="0" marL="0">
+              <a:buNone/>
+            </a:pPr>
+            <a:r>
+              <a:rPr lang="en-US" sz="1250" b="1" dirty="0">
                 <a:solidFill>
                   <a:srgbClr val="2F3C7E"/>
                 </a:solidFill>
@@ -6358,7 +6456,7 @@
               </a:rPr>
               <a:t>Node.js + Express</a:t>
             </a:r>
-            <a:endParaRPr lang="en-US" sz="1400" dirty="0"/>
+            <a:endParaRPr lang="en-US" sz="1250" dirty="0"/>
           </a:p>
         </p:txBody>
       </p:sp>
@@ -6370,8 +6468,8 @@
         </p:nvSpPr>
         <p:spPr>
           <a:xfrm>
-            <a:off x="7269480" y="1892808"/>
-            <a:ext cx="4114800" cy="640080"/>
+            <a:off x="7086600" y="1554480"/>
+            <a:ext cx="4297680" cy="530352"/>
           </a:xfrm>
           <a:prstGeom prst="rect">
             <a:avLst/>
@@ -6385,12 +6483,12 @@
           <a:p>
             <a:pPr indent="0" marL="0">
               <a:lnSpc>
-                <a:spcPct val="115000"/>
+                <a:spcPct val="108000"/>
               </a:lnSpc>
               <a:buNone/>
             </a:pPr>
             <a:r>
-              <a:rPr lang="en-US" sz="1100" dirty="0">
+              <a:rPr lang="en-US" sz="980" dirty="0">
                 <a:solidFill>
                   <a:srgbClr val="5B5B5B"/>
                 </a:solidFill>
@@ -6398,9 +6496,9 @@
                 <a:ea typeface="Calibri" pitchFamily="34" charset="-122"/>
                 <a:cs typeface="Calibri" pitchFamily="34" charset="-120"/>
               </a:rPr>
-              <a:t>HTTP APIs for all four services.</a:t>
-            </a:r>
-            <a:endParaRPr lang="en-US" sz="1100" dirty="0"/>
+              <a:t>HTTP APIs for all four backend services.</a:t>
+            </a:r>
+            <a:endParaRPr lang="en-US" sz="980" dirty="0"/>
           </a:p>
         </p:txBody>
       </p:sp>
@@ -6412,12 +6510,12 @@
         </p:nvSpPr>
         <p:spPr>
           <a:xfrm>
-            <a:off x="548640" y="2834640"/>
-            <a:ext cx="5303520" cy="1188720"/>
+            <a:off x="548640" y="2286000"/>
+            <a:ext cx="5303520" cy="932688"/>
           </a:xfrm>
           <a:prstGeom prst="roundRect">
             <a:avLst>
-              <a:gd name="adj" fmla="val 6154"/>
+              <a:gd name="adj" fmla="val 7843"/>
             </a:avLst>
           </a:prstGeom>
           <a:solidFill>
@@ -6439,8 +6537,8 @@
         </p:nvSpPr>
         <p:spPr>
           <a:xfrm>
-            <a:off x="777240" y="3108960"/>
-            <a:ext cx="640080" cy="640080"/>
+            <a:off x="713232" y="2459736"/>
+            <a:ext cx="530352" cy="530352"/>
           </a:xfrm>
           <a:prstGeom prst="ellipse">
             <a:avLst/>
@@ -6459,8 +6557,8 @@
         </p:nvSpPr>
         <p:spPr>
           <a:xfrm>
-            <a:off x="777240" y="3108960"/>
-            <a:ext cx="640080" cy="640080"/>
+            <a:off x="713232" y="2459736"/>
+            <a:ext cx="530352" cy="530352"/>
           </a:xfrm>
           <a:prstGeom prst="rect">
             <a:avLst/>
@@ -6476,7 +6574,7 @@
               <a:buNone/>
             </a:pPr>
             <a:r>
-              <a:rPr lang="en-US" sz="1600" b="1" dirty="0">
+              <a:rPr lang="en-US" sz="1300" b="1" dirty="0">
                 <a:solidFill>
                   <a:srgbClr val="FFFFFF"/>
                 </a:solidFill>
@@ -6486,7 +6584,7 @@
               </a:rPr>
               <a:t>3</a:t>
             </a:r>
-            <a:endParaRPr lang="en-US" sz="1600" dirty="0"/>
+            <a:endParaRPr lang="en-US" sz="1300" dirty="0"/>
           </a:p>
         </p:txBody>
       </p:sp>
@@ -6498,24 +6596,24 @@
         </p:nvSpPr>
         <p:spPr>
           <a:xfrm>
-            <a:off x="1600200" y="2971800"/>
-            <a:ext cx="4023360" cy="320040"/>
-          </a:xfrm>
-          <a:prstGeom prst="rect">
-            <a:avLst/>
-          </a:prstGeom>
-          <a:noFill/>
-          <a:ln/>
-        </p:spPr>
-        <p:txBody>
-          <a:bodyPr wrap="square" lIns="0" tIns="0" rIns="0" bIns="0" rtlCol="0" anchor="ctr"/>
-          <a:lstStyle/>
-          <a:p>
-            <a:pPr indent="0" marL="0">
-              <a:buNone/>
-            </a:pPr>
-            <a:r>
-              <a:rPr lang="en-US" sz="1400" b="1" dirty="0">
+            <a:off x="1417320" y="2359152"/>
+            <a:ext cx="4251960" cy="274320"/>
+          </a:xfrm>
+          <a:prstGeom prst="rect">
+            <a:avLst/>
+          </a:prstGeom>
+          <a:noFill/>
+          <a:ln/>
+        </p:spPr>
+        <p:txBody>
+          <a:bodyPr wrap="square" lIns="0" tIns="0" rIns="0" bIns="0" rtlCol="0" anchor="ctr"/>
+          <a:lstStyle/>
+          <a:p>
+            <a:pPr indent="0" marL="0">
+              <a:buNone/>
+            </a:pPr>
+            <a:r>
+              <a:rPr lang="en-US" sz="1250" b="1" dirty="0">
                 <a:solidFill>
                   <a:srgbClr val="2F3C7E"/>
                 </a:solidFill>
@@ -6525,7 +6623,7 @@
               </a:rPr>
               <a:t>KafkaJS</a:t>
             </a:r>
-            <a:endParaRPr lang="en-US" sz="1400" dirty="0"/>
+            <a:endParaRPr lang="en-US" sz="1250" dirty="0"/>
           </a:p>
         </p:txBody>
       </p:sp>
@@ -6537,8 +6635,8 @@
         </p:nvSpPr>
         <p:spPr>
           <a:xfrm>
-            <a:off x="1600200" y="3310128"/>
-            <a:ext cx="4114800" cy="640080"/>
+            <a:off x="1417320" y="2651760"/>
+            <a:ext cx="4297680" cy="530352"/>
           </a:xfrm>
           <a:prstGeom prst="rect">
             <a:avLst/>
@@ -6552,12 +6650,12 @@
           <a:p>
             <a:pPr indent="0" marL="0">
               <a:lnSpc>
-                <a:spcPct val="115000"/>
+                <a:spcPct val="108000"/>
               </a:lnSpc>
               <a:buNone/>
             </a:pPr>
             <a:r>
-              <a:rPr lang="en-US" sz="1100" dirty="0">
+              <a:rPr lang="en-US" sz="980" dirty="0">
                 <a:solidFill>
                   <a:srgbClr val="5B5B5B"/>
                 </a:solidFill>
@@ -6567,7 +6665,7 @@
               </a:rPr>
               <a:t>Kafka client library used by every service to produce/consume.</a:t>
             </a:r>
-            <a:endParaRPr lang="en-US" sz="1100" dirty="0"/>
+            <a:endParaRPr lang="en-US" sz="980" dirty="0"/>
           </a:p>
         </p:txBody>
       </p:sp>
@@ -6579,12 +6677,12 @@
         </p:nvSpPr>
         <p:spPr>
           <a:xfrm>
-            <a:off x="6217920" y="2834640"/>
-            <a:ext cx="5303520" cy="1188720"/>
+            <a:off x="6217920" y="2286000"/>
+            <a:ext cx="5303520" cy="932688"/>
           </a:xfrm>
           <a:prstGeom prst="roundRect">
             <a:avLst>
-              <a:gd name="adj" fmla="val 6154"/>
+              <a:gd name="adj" fmla="val 7843"/>
             </a:avLst>
           </a:prstGeom>
           <a:solidFill>
@@ -6606,8 +6704,8 @@
         </p:nvSpPr>
         <p:spPr>
           <a:xfrm>
-            <a:off x="6446520" y="3108960"/>
-            <a:ext cx="640080" cy="640080"/>
+            <a:off x="6382512" y="2459736"/>
+            <a:ext cx="530352" cy="530352"/>
           </a:xfrm>
           <a:prstGeom prst="ellipse">
             <a:avLst/>
@@ -6626,8 +6724,8 @@
         </p:nvSpPr>
         <p:spPr>
           <a:xfrm>
-            <a:off x="6446520" y="3108960"/>
-            <a:ext cx="640080" cy="640080"/>
+            <a:off x="6382512" y="2459736"/>
+            <a:ext cx="530352" cy="530352"/>
           </a:xfrm>
           <a:prstGeom prst="rect">
             <a:avLst/>
@@ -6643,7 +6741,7 @@
               <a:buNone/>
             </a:pPr>
             <a:r>
-              <a:rPr lang="en-US" sz="1600" b="1" dirty="0">
+              <a:rPr lang="en-US" sz="1300" b="1" dirty="0">
                 <a:solidFill>
                   <a:srgbClr val="FFFFFF"/>
                 </a:solidFill>
@@ -6653,7 +6751,7 @@
               </a:rPr>
               <a:t>4</a:t>
             </a:r>
-            <a:endParaRPr lang="en-US" sz="1600" dirty="0"/>
+            <a:endParaRPr lang="en-US" sz="1300" dirty="0"/>
           </a:p>
         </p:txBody>
       </p:sp>
@@ -6665,24 +6763,24 @@
         </p:nvSpPr>
         <p:spPr>
           <a:xfrm>
-            <a:off x="7269480" y="2971800"/>
-            <a:ext cx="4023360" cy="320040"/>
-          </a:xfrm>
-          <a:prstGeom prst="rect">
-            <a:avLst/>
-          </a:prstGeom>
-          <a:noFill/>
-          <a:ln/>
-        </p:spPr>
-        <p:txBody>
-          <a:bodyPr wrap="square" lIns="0" tIns="0" rIns="0" bIns="0" rtlCol="0" anchor="ctr"/>
-          <a:lstStyle/>
-          <a:p>
-            <a:pPr indent="0" marL="0">
-              <a:buNone/>
-            </a:pPr>
-            <a:r>
-              <a:rPr lang="en-US" sz="1400" b="1" dirty="0">
+            <a:off x="7086600" y="2359152"/>
+            <a:ext cx="4251960" cy="274320"/>
+          </a:xfrm>
+          <a:prstGeom prst="rect">
+            <a:avLst/>
+          </a:prstGeom>
+          <a:noFill/>
+          <a:ln/>
+        </p:spPr>
+        <p:txBody>
+          <a:bodyPr wrap="square" lIns="0" tIns="0" rIns="0" bIns="0" rtlCol="0" anchor="ctr"/>
+          <a:lstStyle/>
+          <a:p>
+            <a:pPr indent="0" marL="0">
+              <a:buNone/>
+            </a:pPr>
+            <a:r>
+              <a:rPr lang="en-US" sz="1250" b="1" dirty="0">
                 <a:solidFill>
                   <a:srgbClr val="2F3C7E"/>
                 </a:solidFill>
@@ -6692,7 +6790,7 @@
               </a:rPr>
               <a:t>Docker Compose</a:t>
             </a:r>
-            <a:endParaRPr lang="en-US" sz="1400" dirty="0"/>
+            <a:endParaRPr lang="en-US" sz="1250" dirty="0"/>
           </a:p>
         </p:txBody>
       </p:sp>
@@ -6704,8 +6802,8 @@
         </p:nvSpPr>
         <p:spPr>
           <a:xfrm>
-            <a:off x="7269480" y="3310128"/>
-            <a:ext cx="4114800" cy="640080"/>
+            <a:off x="7086600" y="2651760"/>
+            <a:ext cx="4297680" cy="530352"/>
           </a:xfrm>
           <a:prstGeom prst="rect">
             <a:avLst/>
@@ -6719,12 +6817,12 @@
           <a:p>
             <a:pPr indent="0" marL="0">
               <a:lnSpc>
-                <a:spcPct val="115000"/>
+                <a:spcPct val="108000"/>
               </a:lnSpc>
               <a:buNone/>
             </a:pPr>
             <a:r>
-              <a:rPr lang="en-US" sz="1100" dirty="0">
+              <a:rPr lang="en-US" sz="980" dirty="0">
                 <a:solidFill>
                   <a:srgbClr val="5B5B5B"/>
                 </a:solidFill>
@@ -6732,9 +6830,9 @@
                 <a:ea typeface="Calibri" pitchFamily="34" charset="-122"/>
                 <a:cs typeface="Calibri" pitchFamily="34" charset="-120"/>
               </a:rPr>
-              <a:t>One command brings up Kafka, Kafka UI, and all 4 services.</a:t>
-            </a:r>
-            <a:endParaRPr lang="en-US" sz="1100" dirty="0"/>
+              <a:t>One command brings up Kafka, Kafka UI, and every service.</a:t>
+            </a:r>
+            <a:endParaRPr lang="en-US" sz="980" dirty="0"/>
           </a:p>
         </p:txBody>
       </p:sp>
@@ -6746,12 +6844,12 @@
         </p:nvSpPr>
         <p:spPr>
           <a:xfrm>
-            <a:off x="548640" y="4251960"/>
-            <a:ext cx="5303520" cy="1188720"/>
+            <a:off x="548640" y="3383280"/>
+            <a:ext cx="5303520" cy="932688"/>
           </a:xfrm>
           <a:prstGeom prst="roundRect">
             <a:avLst>
-              <a:gd name="adj" fmla="val 6154"/>
+              <a:gd name="adj" fmla="val 7843"/>
             </a:avLst>
           </a:prstGeom>
           <a:solidFill>
@@ -6773,8 +6871,8 @@
         </p:nvSpPr>
         <p:spPr>
           <a:xfrm>
-            <a:off x="777240" y="4526280"/>
-            <a:ext cx="640080" cy="640080"/>
+            <a:off x="713232" y="3557016"/>
+            <a:ext cx="530352" cy="530352"/>
           </a:xfrm>
           <a:prstGeom prst="ellipse">
             <a:avLst/>
@@ -6793,8 +6891,8 @@
         </p:nvSpPr>
         <p:spPr>
           <a:xfrm>
-            <a:off x="777240" y="4526280"/>
-            <a:ext cx="640080" cy="640080"/>
+            <a:off x="713232" y="3557016"/>
+            <a:ext cx="530352" cy="530352"/>
           </a:xfrm>
           <a:prstGeom prst="rect">
             <a:avLst/>
@@ -6810,7 +6908,7 @@
               <a:buNone/>
             </a:pPr>
             <a:r>
-              <a:rPr lang="en-US" sz="1600" b="1" dirty="0">
+              <a:rPr lang="en-US" sz="1300" b="1" dirty="0">
                 <a:solidFill>
                   <a:srgbClr val="FFFFFF"/>
                 </a:solidFill>
@@ -6820,7 +6918,7 @@
               </a:rPr>
               <a:t>5</a:t>
             </a:r>
-            <a:endParaRPr lang="en-US" sz="1600" dirty="0"/>
+            <a:endParaRPr lang="en-US" sz="1300" dirty="0"/>
           </a:p>
         </p:txBody>
       </p:sp>
@@ -6832,24 +6930,24 @@
         </p:nvSpPr>
         <p:spPr>
           <a:xfrm>
-            <a:off x="1600200" y="4389120"/>
-            <a:ext cx="4023360" cy="320040"/>
-          </a:xfrm>
-          <a:prstGeom prst="rect">
-            <a:avLst/>
-          </a:prstGeom>
-          <a:noFill/>
-          <a:ln/>
-        </p:spPr>
-        <p:txBody>
-          <a:bodyPr wrap="square" lIns="0" tIns="0" rIns="0" bIns="0" rtlCol="0" anchor="ctr"/>
-          <a:lstStyle/>
-          <a:p>
-            <a:pPr indent="0" marL="0">
-              <a:buNone/>
-            </a:pPr>
-            <a:r>
-              <a:rPr lang="en-US" sz="1400" b="1" dirty="0">
+            <a:off x="1417320" y="3456432"/>
+            <a:ext cx="4251960" cy="274320"/>
+          </a:xfrm>
+          <a:prstGeom prst="rect">
+            <a:avLst/>
+          </a:prstGeom>
+          <a:noFill/>
+          <a:ln/>
+        </p:spPr>
+        <p:txBody>
+          <a:bodyPr wrap="square" lIns="0" tIns="0" rIns="0" bIns="0" rtlCol="0" anchor="ctr"/>
+          <a:lstStyle/>
+          <a:p>
+            <a:pPr indent="0" marL="0">
+              <a:buNone/>
+            </a:pPr>
+            <a:r>
+              <a:rPr lang="en-US" sz="1250" b="1" dirty="0">
                 <a:solidFill>
                   <a:srgbClr val="2F3C7E"/>
                 </a:solidFill>
@@ -6859,7 +6957,7 @@
               </a:rPr>
               <a:t>Kafka UI</a:t>
             </a:r>
-            <a:endParaRPr lang="en-US" sz="1400" dirty="0"/>
+            <a:endParaRPr lang="en-US" sz="1250" dirty="0"/>
           </a:p>
         </p:txBody>
       </p:sp>
@@ -6871,8 +6969,8 @@
         </p:nvSpPr>
         <p:spPr>
           <a:xfrm>
-            <a:off x="1600200" y="4727448"/>
-            <a:ext cx="4114800" cy="640080"/>
+            <a:off x="1417320" y="3749040"/>
+            <a:ext cx="4297680" cy="530352"/>
           </a:xfrm>
           <a:prstGeom prst="rect">
             <a:avLst/>
@@ -6886,12 +6984,12 @@
           <a:p>
             <a:pPr indent="0" marL="0">
               <a:lnSpc>
-                <a:spcPct val="115000"/>
+                <a:spcPct val="108000"/>
               </a:lnSpc>
               <a:buNone/>
             </a:pPr>
             <a:r>
-              <a:rPr lang="en-US" sz="1100" dirty="0">
+              <a:rPr lang="en-US" sz="980" dirty="0">
                 <a:solidFill>
                   <a:srgbClr val="5B5B5B"/>
                 </a:solidFill>
@@ -6901,7 +6999,7 @@
               </a:rPr>
               <a:t>Visual proof during the demo: live topic &amp; consumer-group offsets.</a:t>
             </a:r>
-            <a:endParaRPr lang="en-US" sz="1100" dirty="0"/>
+            <a:endParaRPr lang="en-US" sz="980" dirty="0"/>
           </a:p>
         </p:txBody>
       </p:sp>
@@ -6913,12 +7011,12 @@
         </p:nvSpPr>
         <p:spPr>
           <a:xfrm>
-            <a:off x="6217920" y="4251960"/>
-            <a:ext cx="5303520" cy="1188720"/>
+            <a:off x="6217920" y="3383280"/>
+            <a:ext cx="5303520" cy="932688"/>
           </a:xfrm>
           <a:prstGeom prst="roundRect">
             <a:avLst>
-              <a:gd name="adj" fmla="val 6154"/>
+              <a:gd name="adj" fmla="val 7843"/>
             </a:avLst>
           </a:prstGeom>
           <a:solidFill>
@@ -6940,8 +7038,8 @@
         </p:nvSpPr>
         <p:spPr>
           <a:xfrm>
-            <a:off x="6446520" y="4526280"/>
-            <a:ext cx="640080" cy="640080"/>
+            <a:off x="6382512" y="3557016"/>
+            <a:ext cx="530352" cy="530352"/>
           </a:xfrm>
           <a:prstGeom prst="ellipse">
             <a:avLst/>
@@ -6960,8 +7058,8 @@
         </p:nvSpPr>
         <p:spPr>
           <a:xfrm>
-            <a:off x="6446520" y="4526280"/>
-            <a:ext cx="640080" cy="640080"/>
+            <a:off x="6382512" y="3557016"/>
+            <a:ext cx="530352" cy="530352"/>
           </a:xfrm>
           <a:prstGeom prst="rect">
             <a:avLst/>
@@ -6977,7 +7075,7 @@
               <a:buNone/>
             </a:pPr>
             <a:r>
-              <a:rPr lang="en-US" sz="1600" b="1" dirty="0">
+              <a:rPr lang="en-US" sz="1300" b="1" dirty="0">
                 <a:solidFill>
                   <a:srgbClr val="FFFFFF"/>
                 </a:solidFill>
@@ -6987,7 +7085,7 @@
               </a:rPr>
               <a:t>6</a:t>
             </a:r>
-            <a:endParaRPr lang="en-US" sz="1600" dirty="0"/>
+            <a:endParaRPr lang="en-US" sz="1300" dirty="0"/>
           </a:p>
         </p:txBody>
       </p:sp>
@@ -6999,24 +7097,24 @@
         </p:nvSpPr>
         <p:spPr>
           <a:xfrm>
-            <a:off x="7269480" y="4389120"/>
-            <a:ext cx="4023360" cy="320040"/>
-          </a:xfrm>
-          <a:prstGeom prst="rect">
-            <a:avLst/>
-          </a:prstGeom>
-          <a:noFill/>
-          <a:ln/>
-        </p:spPr>
-        <p:txBody>
-          <a:bodyPr wrap="square" lIns="0" tIns="0" rIns="0" bIns="0" rtlCol="0" anchor="ctr"/>
-          <a:lstStyle/>
-          <a:p>
-            <a:pPr indent="0" marL="0">
-              <a:buNone/>
-            </a:pPr>
-            <a:r>
-              <a:rPr lang="en-US" sz="1400" b="1" dirty="0">
+            <a:off x="7086600" y="3456432"/>
+            <a:ext cx="4251960" cy="274320"/>
+          </a:xfrm>
+          <a:prstGeom prst="rect">
+            <a:avLst/>
+          </a:prstGeom>
+          <a:noFill/>
+          <a:ln/>
+        </p:spPr>
+        <p:txBody>
+          <a:bodyPr wrap="square" lIns="0" tIns="0" rIns="0" bIns="0" rtlCol="0" anchor="ctr"/>
+          <a:lstStyle/>
+          <a:p>
+            <a:pPr indent="0" marL="0">
+              <a:buNone/>
+            </a:pPr>
+            <a:r>
+              <a:rPr lang="en-US" sz="1250" b="1" dirty="0">
                 <a:solidFill>
                   <a:srgbClr val="2F3C7E"/>
                 </a:solidFill>
@@ -7024,9 +7122,9 @@
                 <a:ea typeface="Calibri" pitchFamily="34" charset="-122"/>
                 <a:cs typeface="Calibri" pitchFamily="34" charset="-120"/>
               </a:rPr>
-              <a:t>GitHub</a:t>
-            </a:r>
-            <a:endParaRPr lang="en-US" sz="1400" dirty="0"/>
+              <a:t>Web Dashboard</a:t>
+            </a:r>
+            <a:endParaRPr lang="en-US" sz="1250" dirty="0"/>
           </a:p>
         </p:txBody>
       </p:sp>
@@ -7038,8 +7136,8 @@
         </p:nvSpPr>
         <p:spPr>
           <a:xfrm>
-            <a:off x="7269480" y="4727448"/>
-            <a:ext cx="4114800" cy="640080"/>
+            <a:off x="7086600" y="3749040"/>
+            <a:ext cx="4297680" cy="530352"/>
           </a:xfrm>
           <a:prstGeom prst="rect">
             <a:avLst/>
@@ -7053,12 +7151,12 @@
           <a:p>
             <a:pPr indent="0" marL="0">
               <a:lnSpc>
-                <a:spcPct val="115000"/>
+                <a:spcPct val="108000"/>
               </a:lnSpc>
               <a:buNone/>
             </a:pPr>
             <a:r>
-              <a:rPr lang="en-US" sz="1100" dirty="0">
+              <a:rPr lang="en-US" sz="980" dirty="0">
                 <a:solidFill>
                   <a:srgbClr val="5B5B5B"/>
                 </a:solidFill>
@@ -7066,9 +7164,9 @@
                 <a:ea typeface="Calibri" pitchFamily="34" charset="-122"/>
                 <a:cs typeface="Calibri" pitchFamily="34" charset="-120"/>
               </a:rPr>
-              <a:t>Full runnable source, README, and demo script.</a:t>
-            </a:r>
-            <a:endParaRPr lang="en-US" sz="1100" dirty="0"/>
+              <a:t>3 role-based apps — Customer, Restaurant, Rider — each with sign-in, at localhost:8081.</a:t>
+            </a:r>
+            <a:endParaRPr lang="en-US" sz="980" dirty="0"/>
           </a:p>
         </p:txBody>
       </p:sp>
@@ -7080,7 +7178,174 @@
         </p:nvSpPr>
         <p:spPr>
           <a:xfrm>
-            <a:off x="548640" y="5760720"/>
+            <a:off x="548640" y="4480560"/>
+            <a:ext cx="5303520" cy="932688"/>
+          </a:xfrm>
+          <a:prstGeom prst="roundRect">
+            <a:avLst>
+              <a:gd name="adj" fmla="val 7843"/>
+            </a:avLst>
+          </a:prstGeom>
+          <a:solidFill>
+            <a:srgbClr val="F7F8FC"/>
+          </a:solidFill>
+          <a:ln w="12700">
+            <a:solidFill>
+              <a:srgbClr val="DADFEE"/>
+            </a:solidFill>
+            <a:prstDash val="solid"/>
+          </a:ln>
+        </p:spPr>
+      </p:sp>
+      <p:sp>
+        <p:nvSpPr>
+          <p:cNvPr id="34" name="Shape 32"/>
+          <p:cNvSpPr/>
+          <p:nvPr/>
+        </p:nvSpPr>
+        <p:spPr>
+          <a:xfrm>
+            <a:off x="713232" y="4654296"/>
+            <a:ext cx="530352" cy="530352"/>
+          </a:xfrm>
+          <a:prstGeom prst="ellipse">
+            <a:avLst/>
+          </a:prstGeom>
+          <a:solidFill>
+            <a:srgbClr val="2F3C7E"/>
+          </a:solidFill>
+          <a:ln/>
+        </p:spPr>
+      </p:sp>
+      <p:sp>
+        <p:nvSpPr>
+          <p:cNvPr id="35" name="Text 33"/>
+          <p:cNvSpPr txBox="1"/>
+          <p:nvPr/>
+        </p:nvSpPr>
+        <p:spPr>
+          <a:xfrm>
+            <a:off x="713232" y="4654296"/>
+            <a:ext cx="530352" cy="530352"/>
+          </a:xfrm>
+          <a:prstGeom prst="rect">
+            <a:avLst/>
+          </a:prstGeom>
+          <a:noFill/>
+          <a:ln/>
+        </p:spPr>
+        <p:txBody>
+          <a:bodyPr wrap="square" lIns="0" tIns="0" rIns="0" bIns="0" rtlCol="0" anchor="ctr"/>
+          <a:lstStyle/>
+          <a:p>
+            <a:pPr algn="ctr" indent="0" marL="0">
+              <a:buNone/>
+            </a:pPr>
+            <a:r>
+              <a:rPr lang="en-US" sz="1300" b="1" dirty="0">
+                <a:solidFill>
+                  <a:srgbClr val="FFFFFF"/>
+                </a:solidFill>
+                <a:latin typeface="Calibri" pitchFamily="34" charset="0"/>
+                <a:ea typeface="Calibri" pitchFamily="34" charset="-122"/>
+                <a:cs typeface="Calibri" pitchFamily="34" charset="-120"/>
+              </a:rPr>
+              <a:t>7</a:t>
+            </a:r>
+            <a:endParaRPr lang="en-US" sz="1300" dirty="0"/>
+          </a:p>
+        </p:txBody>
+      </p:sp>
+      <p:sp>
+        <p:nvSpPr>
+          <p:cNvPr id="36" name="Text 34"/>
+          <p:cNvSpPr txBox="1"/>
+          <p:nvPr/>
+        </p:nvSpPr>
+        <p:spPr>
+          <a:xfrm>
+            <a:off x="1417320" y="4553712"/>
+            <a:ext cx="4251960" cy="274320"/>
+          </a:xfrm>
+          <a:prstGeom prst="rect">
+            <a:avLst/>
+          </a:prstGeom>
+          <a:noFill/>
+          <a:ln/>
+        </p:spPr>
+        <p:txBody>
+          <a:bodyPr wrap="square" lIns="0" tIns="0" rIns="0" bIns="0" rtlCol="0" anchor="ctr"/>
+          <a:lstStyle/>
+          <a:p>
+            <a:pPr indent="0" marL="0">
+              <a:buNone/>
+            </a:pPr>
+            <a:r>
+              <a:rPr lang="en-US" sz="1250" b="1" dirty="0">
+                <a:solidFill>
+                  <a:srgbClr val="2F3C7E"/>
+                </a:solidFill>
+                <a:latin typeface="Calibri" pitchFamily="34" charset="0"/>
+                <a:ea typeface="Calibri" pitchFamily="34" charset="-122"/>
+                <a:cs typeface="Calibri" pitchFamily="34" charset="-120"/>
+              </a:rPr>
+              <a:t>GitHub</a:t>
+            </a:r>
+            <a:endParaRPr lang="en-US" sz="1250" dirty="0"/>
+          </a:p>
+        </p:txBody>
+      </p:sp>
+      <p:sp>
+        <p:nvSpPr>
+          <p:cNvPr id="37" name="Text 35"/>
+          <p:cNvSpPr txBox="1"/>
+          <p:nvPr/>
+        </p:nvSpPr>
+        <p:spPr>
+          <a:xfrm>
+            <a:off x="1417320" y="4846320"/>
+            <a:ext cx="4297680" cy="530352"/>
+          </a:xfrm>
+          <a:prstGeom prst="rect">
+            <a:avLst/>
+          </a:prstGeom>
+          <a:noFill/>
+          <a:ln/>
+        </p:spPr>
+        <p:txBody>
+          <a:bodyPr wrap="square" lIns="0" tIns="0" rIns="0" bIns="0" rtlCol="0" anchor="ctr"/>
+          <a:lstStyle/>
+          <a:p>
+            <a:pPr indent="0" marL="0">
+              <a:lnSpc>
+                <a:spcPct val="108000"/>
+              </a:lnSpc>
+              <a:buNone/>
+            </a:pPr>
+            <a:r>
+              <a:rPr lang="en-US" sz="980" dirty="0">
+                <a:solidFill>
+                  <a:srgbClr val="5B5B5B"/>
+                </a:solidFill>
+                <a:latin typeface="Calibri" pitchFamily="34" charset="0"/>
+                <a:ea typeface="Calibri" pitchFamily="34" charset="-122"/>
+                <a:cs typeface="Calibri" pitchFamily="34" charset="-120"/>
+              </a:rPr>
+              <a:t>Full runnable source, README, and demo script.</a:t>
+            </a:r>
+            <a:endParaRPr lang="en-US" sz="980" dirty="0"/>
+          </a:p>
+        </p:txBody>
+      </p:sp>
+      <p:sp>
+        <p:nvSpPr>
+          <p:cNvPr id="38" name="Shape 36"/>
+          <p:cNvSpPr/>
+          <p:nvPr/>
+        </p:nvSpPr>
+        <p:spPr>
+          <a:xfrm>
+            <a:off x="548640" y="5806440"/>
             <a:ext cx="11064240" cy="685800"/>
           </a:xfrm>
           <a:prstGeom prst="roundRect">
@@ -7096,13 +7361,13 @@
       </p:sp>
       <p:sp>
         <p:nvSpPr>
-          <p:cNvPr id="34" name="Text 32"/>
-          <p:cNvSpPr txBox="1"/>
-          <p:nvPr/>
-        </p:nvSpPr>
-        <p:spPr>
-          <a:xfrm>
-            <a:off x="822960" y="5760720"/>
+          <p:cNvPr id="39" name="Text 37"/>
+          <p:cNvSpPr txBox="1"/>
+          <p:nvPr/>
+        </p:nvSpPr>
+        <p:spPr>
+          <a:xfrm>
+            <a:off x="822960" y="5806440"/>
             <a:ext cx="10607040" cy="685800"/>
           </a:xfrm>
           <a:prstGeom prst="rect">
@@ -7119,7 +7384,7 @@
               <a:buNone/>
             </a:pPr>
             <a:r>
-              <a:rPr lang="en-US" sz="1250" b="1" dirty="0">
+              <a:rPr lang="en-US" sz="1200" b="1" dirty="0">
                 <a:solidFill>
                   <a:srgbClr val="FFFFFF"/>
                 </a:solidFill>
@@ -7133,7 +7398,7 @@
               <a:buNone/>
             </a:pPr>
             <a:r>
-              <a:rPr lang="en-US" sz="1250" dirty="0">
+              <a:rPr lang="en-US" sz="1200" dirty="0">
                 <a:solidFill>
                   <a:srgbClr val="CADCFC"/>
                 </a:solidFill>
@@ -7141,15 +7406,15 @@
                 <a:ea typeface="Calibri" pitchFamily="34" charset="-122"/>
                 <a:cs typeface="Calibri" pitchFamily="34" charset="-120"/>
               </a:rPr>
-              <a:t>order-service / customer-service / rider-service / notification-service / docs / postman / docker-compose.yml</a:t>
-            </a:r>
-            <a:endParaRPr lang="en-US" sz="1250" dirty="0"/>
-          </a:p>
-        </p:txBody>
-      </p:sp>
-      <p:sp>
-        <p:nvSpPr>
-          <p:cNvPr id="35" name="Text 33"/>
+              <a:t>order-service / customer-service / rider-service / notification-service / web / docs / postman / docker-compose.yml</a:t>
+            </a:r>
+            <a:endParaRPr lang="en-US" sz="1200" dirty="0"/>
+          </a:p>
+        </p:txBody>
+      </p:sp>
+      <p:sp>
+        <p:nvSpPr>
+          <p:cNvPr id="40" name="Text 38"/>
           <p:cNvSpPr txBox="1"/>
           <p:nvPr/>
         </p:nvSpPr>
@@ -7188,7 +7453,7 @@
       </p:sp>
       <p:sp>
         <p:nvSpPr>
-          <p:cNvPr id="36" name="Text 34"/>
+          <p:cNvPr id="41" name="Text 39"/>
           <p:cNvSpPr txBox="1"/>
           <p:nvPr/>
         </p:nvSpPr>
@@ -7851,7 +8116,7 @@
                 <a:ea typeface="Calibri" pitchFamily="34" charset="-122"/>
                 <a:cs typeface="Calibri" pitchFamily="34" charset="-120"/>
               </a:rPr>
-              <a:t>Verified live: docker compose stop rider-service → publish 2 status updates → docker compose start rider-service → GET /pickup-pool still returns the missed order.</a:t>
+              <a:t>Verified live: docker compose stop rider-service → publish 2 status updates → docker compose start rider-service → rider app's pickup list still shows the missed order.</a:t>
             </a:r>
             <a:endParaRPr lang="en-US" sz="1150" dirty="0"/>
           </a:p>
@@ -8008,18 +8273,57 @@
       </p:sp>
       <p:sp>
         <p:nvSpPr>
-          <p:cNvPr id="3" name="Shape 1"/>
+          <p:cNvPr id="3" name="Text 1"/>
+          <p:cNvSpPr txBox="1"/>
+          <p:nvPr/>
+        </p:nvSpPr>
+        <p:spPr>
+          <a:xfrm>
+            <a:off x="548640" y="1234440"/>
+            <a:ext cx="11064240" cy="365760"/>
+          </a:xfrm>
+          <a:prstGeom prst="rect">
+            <a:avLst/>
+          </a:prstGeom>
+          <a:noFill/>
+          <a:ln/>
+        </p:spPr>
+        <p:txBody>
+          <a:bodyPr wrap="square" lIns="0" tIns="0" rIns="0" bIns="0" rtlCol="0" anchor="ctr"/>
+          <a:lstStyle/>
+          <a:p>
+            <a:pPr indent="0" marL="0">
+              <a:buNone/>
+            </a:pPr>
+            <a:r>
+              <a:rPr lang="en-US" sz="1300" i="1" dirty="0">
+                <a:solidFill>
+                  <a:srgbClr val="5B5B5B"/>
+                </a:solidFill>
+                <a:latin typeface="Calibri" pitchFamily="34" charset="0"/>
+                <a:ea typeface="Calibri" pitchFamily="34" charset="-122"/>
+                <a:cs typeface="Calibri" pitchFamily="34" charset="-120"/>
+              </a:rPr>
+              <a:t>Two ways to see it work — pick either, or mix both live:</a:t>
+            </a:r>
+            <a:endParaRPr lang="en-US" sz="1300" dirty="0"/>
+          </a:p>
+        </p:txBody>
+      </p:sp>
+      <p:sp>
+        <p:nvSpPr>
+          <p:cNvPr id="4" name="Shape 2"/>
           <p:cNvSpPr/>
           <p:nvPr/>
         </p:nvSpPr>
         <p:spPr>
           <a:xfrm>
-            <a:off x="548640" y="1371600"/>
-            <a:ext cx="5394960" cy="4572000"/>
+            <a:off x="548640" y="1691640"/>
+            <a:ext cx="5440680" cy="4343400"/>
           </a:xfrm>
           <a:prstGeom prst="roundRect">
             <a:avLst>
-              <a:gd name="adj" fmla="val 1600"/>
+              <a:gd name="adj" fmla="val 1684"/>
             </a:avLst>
           </a:prstGeom>
           <a:solidFill>
@@ -8030,14 +8334,14 @@
       </p:sp>
       <p:sp>
         <p:nvSpPr>
-          <p:cNvPr id="4" name="Text 2"/>
-          <p:cNvSpPr txBox="1"/>
-          <p:nvPr/>
-        </p:nvSpPr>
-        <p:spPr>
-          <a:xfrm>
-            <a:off x="777240" y="1508760"/>
-            <a:ext cx="4572000" cy="320040"/>
+          <p:cNvPr id="5" name="Text 3"/>
+          <p:cNvSpPr txBox="1"/>
+          <p:nvPr/>
+        </p:nvSpPr>
+        <p:spPr>
+          <a:xfrm>
+            <a:off x="777240" y="1828800"/>
+            <a:ext cx="4937760" cy="320040"/>
           </a:xfrm>
           <a:prstGeom prst="rect">
             <a:avLst/>
@@ -8061,7 +8365,7 @@
                 <a:ea typeface="Calibri" pitchFamily="34" charset="-122"/>
                 <a:cs typeface="Calibri" pitchFamily="34" charset="-120"/>
               </a:rPr>
-              <a:t>Terminal</a:t>
+              <a:t>Terminal + Kafka UI</a:t>
             </a:r>
             <a:endParaRPr lang="en-US" sz="1300" dirty="0"/>
           </a:p>
@@ -8069,14 +8373,14 @@
       </p:sp>
       <p:sp>
         <p:nvSpPr>
-          <p:cNvPr id="5" name="Text 3"/>
-          <p:cNvSpPr txBox="1"/>
-          <p:nvPr/>
-        </p:nvSpPr>
-        <p:spPr>
-          <a:xfrm>
-            <a:off x="777240" y="1874520"/>
-            <a:ext cx="4937760" cy="3931920"/>
+          <p:cNvPr id="6" name="Text 4"/>
+          <p:cNvSpPr txBox="1"/>
+          <p:nvPr/>
+        </p:nvSpPr>
+        <p:spPr>
+          <a:xfrm>
+            <a:off x="777240" y="2194560"/>
+            <a:ext cx="4937760" cy="3749040"/>
           </a:xfrm>
           <a:prstGeom prst="rect">
             <a:avLst/>
@@ -8095,7 +8399,7 @@
               <a:buNone/>
             </a:pPr>
             <a:r>
-              <a:rPr lang="en-US" sz="1150" dirty="0">
+              <a:rPr lang="en-US" sz="1100" dirty="0">
                 <a:solidFill>
                   <a:srgbClr val="F9E795"/>
                 </a:solidFill>
@@ -8113,7 +8417,7 @@
               <a:buNone/>
             </a:pPr>
             <a:r>
-              <a:rPr lang="en-US" sz="1150" dirty="0">
+              <a:rPr lang="en-US" sz="1100" dirty="0">
                 <a:solidFill>
                   <a:srgbClr val="F9E795"/>
                 </a:solidFill>
@@ -8131,7 +8435,7 @@
               <a:buNone/>
             </a:pPr>
             <a:r>
-              <a:rPr lang="en-US" sz="1150" dirty="0">
+              <a:rPr lang="en-US" sz="1100" dirty="0">
                 <a:solidFill>
                   <a:srgbClr val="9FB3E8"/>
                 </a:solidFill>
@@ -8149,7 +8453,7 @@
               <a:buNone/>
             </a:pPr>
             <a:r>
-              <a:rPr lang="en-US" sz="1150" dirty="0">
+              <a:rPr lang="en-US" sz="1100" dirty="0">
                 <a:solidFill>
                   <a:srgbClr val="9FB3E8"/>
                 </a:solidFill>
@@ -8157,7 +8461,7 @@
                 <a:ea typeface="Courier New" pitchFamily="34" charset="-122"/>
                 <a:cs typeface="Courier New" pitchFamily="34" charset="-120"/>
               </a:rPr>
-              <a:t>== CONFIRMED ==
+              <a:t>== CONFIRMED / PREPARING ==
 </a:t>
             </a:r>
             <a:pPr indent="0" marL="0">
@@ -8167,7 +8471,7 @@
               <a:buNone/>
             </a:pPr>
             <a:r>
-              <a:rPr lang="en-US" sz="1150" dirty="0">
+              <a:rPr lang="en-US" sz="1100" dirty="0">
                 <a:solidFill>
                   <a:srgbClr val="9FB3E8"/>
                 </a:solidFill>
@@ -8185,7 +8489,7 @@
               <a:buNone/>
             </a:pPr>
             <a:r>
-              <a:rPr lang="en-US" sz="1150" dirty="0">
+              <a:rPr lang="en-US" sz="1100" dirty="0">
                 <a:solidFill>
                   <a:srgbClr val="9FB3E8"/>
                 </a:solidFill>
@@ -8193,7 +8497,7 @@
                 <a:ea typeface="Courier New" pitchFamily="34" charset="-122"/>
                 <a:cs typeface="Courier New" pitchFamily="34" charset="-120"/>
               </a:rPr>
-              <a:t>== PICKED_UP by rider-9 ==
+              <a:t>== PICKED_UP / DELIVERED ==
 </a:t>
             </a:r>
             <a:pPr indent="0" marL="0">
@@ -8203,15 +8507,15 @@
               <a:buNone/>
             </a:pPr>
             <a:r>
-              <a:rPr lang="en-US" sz="1150" dirty="0">
-                <a:solidFill>
-                  <a:srgbClr val="9FB3E8"/>
+              <a:rPr lang="en-US" sz="1100" dirty="0">
+                <a:solidFill>
+                  <a:srgbClr val="E8ECFA"/>
                 </a:solidFill>
                 <a:latin typeface="Courier New" pitchFamily="34" charset="0"/>
                 <a:ea typeface="Courier New" pitchFamily="34" charset="-122"/>
                 <a:cs typeface="Courier New" pitchFamily="34" charset="-120"/>
               </a:rPr>
-              <a:t>== DELIVERED ==
+              <a:t>customer feed: 5 events received
 </a:t>
             </a:r>
             <a:pPr indent="0" marL="0">
@@ -8221,7 +8525,7 @@
               <a:buNone/>
             </a:pPr>
             <a:r>
-              <a:rPr lang="en-US" sz="1150" dirty="0">
+              <a:rPr lang="en-US" sz="1100" dirty="0">
                 <a:solidFill>
                   <a:srgbClr val="E8ECFA"/>
                 </a:solidFill>
@@ -8229,7 +8533,7 @@
                 <a:ea typeface="Courier New" pitchFamily="34" charset="-122"/>
                 <a:cs typeface="Courier New" pitchFamily="34" charset="-120"/>
               </a:rPr>
-              <a:t>customer feed: 5 events received
+              <a:t>rider pickup-pool: []
 </a:t>
             </a:r>
             <a:pPr indent="0" marL="0">
@@ -8239,7 +8543,7 @@
               <a:buNone/>
             </a:pPr>
             <a:r>
-              <a:rPr lang="en-US" sz="1150" dirty="0">
+              <a:rPr lang="en-US" sz="1100" dirty="0">
                 <a:solidFill>
                   <a:srgbClr val="E8ECFA"/>
                 </a:solidFill>
@@ -8247,7 +8551,7 @@
                 <a:ea typeface="Courier New" pitchFamily="34" charset="-122"/>
                 <a:cs typeface="Courier New" pitchFamily="34" charset="-120"/>
               </a:rPr>
-              <a:t>rider pickup-pool: []
+              <a:t>notifications sent: 5
 </a:t>
             </a:r>
             <a:pPr indent="0" marL="0">
@@ -8257,29 +8561,113 @@
               <a:buNone/>
             </a:pPr>
             <a:r>
-              <a:rPr lang="en-US" sz="1150" dirty="0">
-                <a:solidFill>
-                  <a:srgbClr val="E8ECFA"/>
+              <a:rPr lang="en-US" sz="1100" dirty="0">
+                <a:solidFill>
+                  <a:srgbClr val="F9E795"/>
                 </a:solidFill>
                 <a:latin typeface="Courier New" pitchFamily="34" charset="0"/>
                 <a:ea typeface="Courier New" pitchFamily="34" charset="-122"/>
                 <a:cs typeface="Courier New" pitchFamily="34" charset="-120"/>
               </a:rPr>
-              <a:t>notifications sent: 5</a:t>
-            </a:r>
-            <a:endParaRPr lang="en-US" sz="1150" dirty="0"/>
-          </a:p>
-        </p:txBody>
-      </p:sp>
-      <p:sp>
-        <p:nvSpPr>
-          <p:cNvPr id="6" name="Shape 4"/>
+              <a:t>Kafka UI: localhost:8090
+</a:t>
+            </a:r>
+            <a:pPr indent="0" marL="0">
+              <a:lnSpc>
+                <a:spcPct val="120000"/>
+              </a:lnSpc>
+              <a:buNone/>
+            </a:pPr>
+            <a:r>
+              <a:rPr lang="en-US" sz="1100" dirty="0">
+                <a:solidFill>
+                  <a:srgbClr val="AAB2D8"/>
+                </a:solidFill>
+                <a:latin typeface="Courier New" pitchFamily="34" charset="0"/>
+                <a:ea typeface="Courier New" pitchFamily="34" charset="-122"/>
+                <a:cs typeface="Courier New" pitchFamily="34" charset="-120"/>
+              </a:rPr>
+              <a:t>watch topic + consumer-group offsets live</a:t>
+            </a:r>
+            <a:endParaRPr lang="en-US" sz="1100" dirty="0"/>
+          </a:p>
+        </p:txBody>
+      </p:sp>
+      <p:sp>
+        <p:nvSpPr>
+          <p:cNvPr id="7" name="Shape 5"/>
           <p:cNvSpPr/>
           <p:nvPr/>
         </p:nvSpPr>
         <p:spPr>
           <a:xfrm>
-            <a:off x="6263640" y="1417320"/>
+            <a:off x="6172200" y="1691640"/>
+            <a:ext cx="5440680" cy="4343400"/>
+          </a:xfrm>
+          <a:prstGeom prst="roundRect">
+            <a:avLst>
+              <a:gd name="adj" fmla="val 1684"/>
+            </a:avLst>
+          </a:prstGeom>
+          <a:solidFill>
+            <a:srgbClr val="F7F8FC"/>
+          </a:solidFill>
+          <a:ln w="12700">
+            <a:solidFill>
+              <a:srgbClr val="DADFEE"/>
+            </a:solidFill>
+            <a:prstDash val="solid"/>
+          </a:ln>
+        </p:spPr>
+      </p:sp>
+      <p:sp>
+        <p:nvSpPr>
+          <p:cNvPr id="8" name="Text 6"/>
+          <p:cNvSpPr txBox="1"/>
+          <p:nvPr/>
+        </p:nvSpPr>
+        <p:spPr>
+          <a:xfrm>
+            <a:off x="6400800" y="1828800"/>
+            <a:ext cx="4937760" cy="320040"/>
+          </a:xfrm>
+          <a:prstGeom prst="rect">
+            <a:avLst/>
+          </a:prstGeom>
+          <a:noFill/>
+          <a:ln/>
+        </p:spPr>
+        <p:txBody>
+          <a:bodyPr wrap="square" lIns="0" tIns="0" rIns="0" bIns="0" rtlCol="0" anchor="ctr"/>
+          <a:lstStyle/>
+          <a:p>
+            <a:pPr indent="0" marL="0">
+              <a:buNone/>
+            </a:pPr>
+            <a:r>
+              <a:rPr lang="en-US" sz="1300" b="1" dirty="0">
+                <a:solidFill>
+                  <a:srgbClr val="2F3C7E"/>
+                </a:solidFill>
+                <a:latin typeface="Calibri" pitchFamily="34" charset="0"/>
+                <a:ea typeface="Calibri" pitchFamily="34" charset="-122"/>
+                <a:cs typeface="Calibri" pitchFamily="34" charset="-120"/>
+              </a:rPr>
+              <a:t>Web Dashboard — localhost:8081</a:t>
+            </a:r>
+            <a:endParaRPr lang="en-US" sz="1300" dirty="0"/>
+          </a:p>
+        </p:txBody>
+      </p:sp>
+      <p:sp>
+        <p:nvSpPr>
+          <p:cNvPr id="9" name="Shape 7"/>
+          <p:cNvSpPr/>
+          <p:nvPr/>
+        </p:nvSpPr>
+        <p:spPr>
+          <a:xfrm>
+            <a:off x="6400800" y="2286000"/>
             <a:ext cx="502920" cy="502920"/>
           </a:xfrm>
           <a:prstGeom prst="ellipse">
@@ -8293,13 +8681,13 @@
       </p:sp>
       <p:sp>
         <p:nvSpPr>
-          <p:cNvPr id="7" name="Text 5"/>
-          <p:cNvSpPr txBox="1"/>
-          <p:nvPr/>
-        </p:nvSpPr>
-        <p:spPr>
-          <a:xfrm>
-            <a:off x="6263640" y="1417320"/>
+          <p:cNvPr id="10" name="Text 8"/>
+          <p:cNvSpPr txBox="1"/>
+          <p:nvPr/>
+        </p:nvSpPr>
+        <p:spPr>
+          <a:xfrm>
+            <a:off x="6400800" y="2286000"/>
             <a:ext cx="502920" cy="502920"/>
           </a:xfrm>
           <a:prstGeom prst="rect">
@@ -8332,30 +8720,30 @@
       </p:sp>
       <p:sp>
         <p:nvSpPr>
-          <p:cNvPr id="8" name="Text 6"/>
-          <p:cNvSpPr txBox="1"/>
-          <p:nvPr/>
-        </p:nvSpPr>
-        <p:spPr>
-          <a:xfrm>
-            <a:off x="6903720" y="1371600"/>
-            <a:ext cx="4754880" cy="365760"/>
-          </a:xfrm>
-          <a:prstGeom prst="rect">
-            <a:avLst/>
-          </a:prstGeom>
-          <a:noFill/>
-          <a:ln/>
-        </p:spPr>
-        <p:txBody>
-          <a:bodyPr wrap="square" lIns="0" tIns="0" rIns="0" bIns="0" rtlCol="0" anchor="ctr"/>
-          <a:lstStyle/>
-          <a:p>
-            <a:pPr indent="0" marL="0">
-              <a:buNone/>
-            </a:pPr>
-            <a:r>
-              <a:rPr lang="en-US" sz="1350" b="1" dirty="0">
+          <p:cNvPr id="11" name="Text 9"/>
+          <p:cNvSpPr txBox="1"/>
+          <p:nvPr/>
+        </p:nvSpPr>
+        <p:spPr>
+          <a:xfrm>
+            <a:off x="7040880" y="2267712"/>
+            <a:ext cx="4297680" cy="320040"/>
+          </a:xfrm>
+          <a:prstGeom prst="rect">
+            <a:avLst/>
+          </a:prstGeom>
+          <a:noFill/>
+          <a:ln/>
+        </p:spPr>
+        <p:txBody>
+          <a:bodyPr wrap="square" lIns="0" tIns="0" rIns="0" bIns="0" rtlCol="0" anchor="ctr"/>
+          <a:lstStyle/>
+          <a:p>
+            <a:pPr indent="0" marL="0">
+              <a:buNone/>
+            </a:pPr>
+            <a:r>
+              <a:rPr lang="en-US" sz="1300" b="1" dirty="0">
                 <a:solidFill>
                   <a:srgbClr val="2F3C7E"/>
                 </a:solidFill>
@@ -8363,22 +8751,22 @@
                 <a:ea typeface="Calibri" pitchFamily="34" charset="-122"/>
                 <a:cs typeface="Calibri" pitchFamily="34" charset="-120"/>
               </a:rPr>
-              <a:t>Bring the whole stack up with one command</a:t>
-            </a:r>
-            <a:endParaRPr lang="en-US" sz="1350" dirty="0"/>
-          </a:p>
-        </p:txBody>
-      </p:sp>
-      <p:sp>
-        <p:nvSpPr>
-          <p:cNvPr id="9" name="Text 7"/>
-          <p:cNvSpPr txBox="1"/>
-          <p:nvPr/>
-        </p:nvSpPr>
-        <p:spPr>
-          <a:xfrm>
-            <a:off x="6903720" y="1709928"/>
-            <a:ext cx="4754880" cy="640080"/>
+              <a:t>Customer</a:t>
+            </a:r>
+            <a:endParaRPr lang="en-US" sz="1300" dirty="0"/>
+          </a:p>
+        </p:txBody>
+      </p:sp>
+      <p:sp>
+        <p:nvSpPr>
+          <p:cNvPr id="12" name="Text 10"/>
+          <p:cNvSpPr txBox="1"/>
+          <p:nvPr/>
+        </p:nvSpPr>
+        <p:spPr>
+          <a:xfrm>
+            <a:off x="7040880" y="2587752"/>
+            <a:ext cx="4297680" cy="640080"/>
           </a:xfrm>
           <a:prstGeom prst="rect">
             <a:avLst/>
@@ -8397,7 +8785,7 @@
               <a:buNone/>
             </a:pPr>
             <a:r>
-              <a:rPr lang="en-US" sz="1150" dirty="0">
+              <a:rPr lang="en-US" sz="1100" dirty="0">
                 <a:solidFill>
                   <a:srgbClr val="5B5B5B"/>
                 </a:solidFill>
@@ -8405,21 +8793,21 @@
                 <a:ea typeface="Calibri" pitchFamily="34" charset="-122"/>
                 <a:cs typeface="Calibri" pitchFamily="34" charset="-120"/>
               </a:rPr>
-              <a:t>docker compose up --build — Kafka, Kafka UI, and all 4 services.</a:t>
-            </a:r>
-            <a:endParaRPr lang="en-US" sz="1150" dirty="0"/>
-          </a:p>
-        </p:txBody>
-      </p:sp>
-      <p:sp>
-        <p:nvSpPr>
-          <p:cNvPr id="10" name="Shape 8"/>
+              <a:t>Sign in, browse a restaurant's menu, add to cart, place the order.</a:t>
+            </a:r>
+            <a:endParaRPr lang="en-US" sz="1100" dirty="0"/>
+          </a:p>
+        </p:txBody>
+      </p:sp>
+      <p:sp>
+        <p:nvSpPr>
+          <p:cNvPr id="13" name="Shape 11"/>
           <p:cNvSpPr/>
           <p:nvPr/>
         </p:nvSpPr>
         <p:spPr>
           <a:xfrm>
-            <a:off x="6263640" y="2532888"/>
+            <a:off x="6400800" y="3429000"/>
             <a:ext cx="502920" cy="502920"/>
           </a:xfrm>
           <a:prstGeom prst="ellipse">
@@ -8433,13 +8821,13 @@
       </p:sp>
       <p:sp>
         <p:nvSpPr>
-          <p:cNvPr id="11" name="Text 9"/>
-          <p:cNvSpPr txBox="1"/>
-          <p:nvPr/>
-        </p:nvSpPr>
-        <p:spPr>
-          <a:xfrm>
-            <a:off x="6263640" y="2532888"/>
+          <p:cNvPr id="14" name="Text 12"/>
+          <p:cNvSpPr txBox="1"/>
+          <p:nvPr/>
+        </p:nvSpPr>
+        <p:spPr>
+          <a:xfrm>
+            <a:off x="6400800" y="3429000"/>
             <a:ext cx="502920" cy="502920"/>
           </a:xfrm>
           <a:prstGeom prst="rect">
@@ -8472,30 +8860,30 @@
       </p:sp>
       <p:sp>
         <p:nvSpPr>
-          <p:cNvPr id="12" name="Text 10"/>
-          <p:cNvSpPr txBox="1"/>
-          <p:nvPr/>
-        </p:nvSpPr>
-        <p:spPr>
-          <a:xfrm>
-            <a:off x="6903720" y="2487168"/>
-            <a:ext cx="4754880" cy="365760"/>
-          </a:xfrm>
-          <a:prstGeom prst="rect">
-            <a:avLst/>
-          </a:prstGeom>
-          <a:noFill/>
-          <a:ln/>
-        </p:spPr>
-        <p:txBody>
-          <a:bodyPr wrap="square" lIns="0" tIns="0" rIns="0" bIns="0" rtlCol="0" anchor="ctr"/>
-          <a:lstStyle/>
-          <a:p>
-            <a:pPr indent="0" marL="0">
-              <a:buNone/>
-            </a:pPr>
-            <a:r>
-              <a:rPr lang="en-US" sz="1350" b="1" dirty="0">
+          <p:cNvPr id="15" name="Text 13"/>
+          <p:cNvSpPr txBox="1"/>
+          <p:nvPr/>
+        </p:nvSpPr>
+        <p:spPr>
+          <a:xfrm>
+            <a:off x="7040880" y="3410712"/>
+            <a:ext cx="4297680" cy="320040"/>
+          </a:xfrm>
+          <a:prstGeom prst="rect">
+            <a:avLst/>
+          </a:prstGeom>
+          <a:noFill/>
+          <a:ln/>
+        </p:spPr>
+        <p:txBody>
+          <a:bodyPr wrap="square" lIns="0" tIns="0" rIns="0" bIns="0" rtlCol="0" anchor="ctr"/>
+          <a:lstStyle/>
+          <a:p>
+            <a:pPr indent="0" marL="0">
+              <a:buNone/>
+            </a:pPr>
+            <a:r>
+              <a:rPr lang="en-US" sz="1300" b="1" dirty="0">
                 <a:solidFill>
                   <a:srgbClr val="2F3C7E"/>
                 </a:solidFill>
@@ -8503,22 +8891,22 @@
                 <a:ea typeface="Calibri" pitchFamily="34" charset="-122"/>
                 <a:cs typeface="Calibri" pitchFamily="34" charset="-120"/>
               </a:rPr>
-              <a:t>Drive the order through its lifecycle</a:t>
-            </a:r>
-            <a:endParaRPr lang="en-US" sz="1350" dirty="0"/>
-          </a:p>
-        </p:txBody>
-      </p:sp>
-      <p:sp>
-        <p:nvSpPr>
-          <p:cNvPr id="13" name="Text 11"/>
-          <p:cNvSpPr txBox="1"/>
-          <p:nvPr/>
-        </p:nvSpPr>
-        <p:spPr>
-          <a:xfrm>
-            <a:off x="6903720" y="2825496"/>
-            <a:ext cx="4754880" cy="640080"/>
+              <a:t>Restaurant</a:t>
+            </a:r>
+            <a:endParaRPr lang="en-US" sz="1300" dirty="0"/>
+          </a:p>
+        </p:txBody>
+      </p:sp>
+      <p:sp>
+        <p:nvSpPr>
+          <p:cNvPr id="16" name="Text 14"/>
+          <p:cNvSpPr txBox="1"/>
+          <p:nvPr/>
+        </p:nvSpPr>
+        <p:spPr>
+          <a:xfrm>
+            <a:off x="7040880" y="3730752"/>
+            <a:ext cx="4297680" cy="640080"/>
           </a:xfrm>
           <a:prstGeom prst="rect">
             <a:avLst/>
@@ -8537,7 +8925,7 @@
               <a:buNone/>
             </a:pPr>
             <a:r>
-              <a:rPr lang="en-US" sz="1150" dirty="0">
+              <a:rPr lang="en-US" sz="1100" dirty="0">
                 <a:solidFill>
                   <a:srgbClr val="5B5B5B"/>
                 </a:solidFill>
@@ -8545,21 +8933,21 @@
                 <a:ea typeface="Calibri" pitchFamily="34" charset="-122"/>
                 <a:cs typeface="Calibri" pitchFamily="34" charset="-120"/>
               </a:rPr>
-              <a:t>postman/demo.sh or postman/demo-requests.http (Postman / REST Client).</a:t>
-            </a:r>
-            <a:endParaRPr lang="en-US" sz="1150" dirty="0"/>
-          </a:p>
-        </p:txBody>
-      </p:sp>
-      <p:sp>
-        <p:nvSpPr>
-          <p:cNvPr id="14" name="Shape 12"/>
+              <a:t>Sign in on a second tab — confirm, start preparing, mark ready.</a:t>
+            </a:r>
+            <a:endParaRPr lang="en-US" sz="1100" dirty="0"/>
+          </a:p>
+        </p:txBody>
+      </p:sp>
+      <p:sp>
+        <p:nvSpPr>
+          <p:cNvPr id="17" name="Shape 15"/>
           <p:cNvSpPr/>
           <p:nvPr/>
         </p:nvSpPr>
         <p:spPr>
           <a:xfrm>
-            <a:off x="6263640" y="3648456"/>
+            <a:off x="6400800" y="4572000"/>
             <a:ext cx="502920" cy="502920"/>
           </a:xfrm>
           <a:prstGeom prst="ellipse">
@@ -8573,13 +8961,13 @@
       </p:sp>
       <p:sp>
         <p:nvSpPr>
-          <p:cNvPr id="15" name="Text 13"/>
-          <p:cNvSpPr txBox="1"/>
-          <p:nvPr/>
-        </p:nvSpPr>
-        <p:spPr>
-          <a:xfrm>
-            <a:off x="6263640" y="3648456"/>
+          <p:cNvPr id="18" name="Text 16"/>
+          <p:cNvSpPr txBox="1"/>
+          <p:nvPr/>
+        </p:nvSpPr>
+        <p:spPr>
+          <a:xfrm>
+            <a:off x="6400800" y="4572000"/>
             <a:ext cx="502920" cy="502920"/>
           </a:xfrm>
           <a:prstGeom prst="rect">
@@ -8612,30 +9000,30 @@
       </p:sp>
       <p:sp>
         <p:nvSpPr>
-          <p:cNvPr id="16" name="Text 14"/>
-          <p:cNvSpPr txBox="1"/>
-          <p:nvPr/>
-        </p:nvSpPr>
-        <p:spPr>
-          <a:xfrm>
-            <a:off x="6903720" y="3602736"/>
-            <a:ext cx="4754880" cy="365760"/>
-          </a:xfrm>
-          <a:prstGeom prst="rect">
-            <a:avLst/>
-          </a:prstGeom>
-          <a:noFill/>
-          <a:ln/>
-        </p:spPr>
-        <p:txBody>
-          <a:bodyPr wrap="square" lIns="0" tIns="0" rIns="0" bIns="0" rtlCol="0" anchor="ctr"/>
-          <a:lstStyle/>
-          <a:p>
-            <a:pPr indent="0" marL="0">
-              <a:buNone/>
-            </a:pPr>
-            <a:r>
-              <a:rPr lang="en-US" sz="1350" b="1" dirty="0">
+          <p:cNvPr id="19" name="Text 17"/>
+          <p:cNvSpPr txBox="1"/>
+          <p:nvPr/>
+        </p:nvSpPr>
+        <p:spPr>
+          <a:xfrm>
+            <a:off x="7040880" y="4553712"/>
+            <a:ext cx="4297680" cy="320040"/>
+          </a:xfrm>
+          <a:prstGeom prst="rect">
+            <a:avLst/>
+          </a:prstGeom>
+          <a:noFill/>
+          <a:ln/>
+        </p:spPr>
+        <p:txBody>
+          <a:bodyPr wrap="square" lIns="0" tIns="0" rIns="0" bIns="0" rtlCol="0" anchor="ctr"/>
+          <a:lstStyle/>
+          <a:p>
+            <a:pPr indent="0" marL="0">
+              <a:buNone/>
+            </a:pPr>
+            <a:r>
+              <a:rPr lang="en-US" sz="1300" b="1" dirty="0">
                 <a:solidFill>
                   <a:srgbClr val="2F3C7E"/>
                 </a:solidFill>
@@ -8643,22 +9031,22 @@
                 <a:ea typeface="Calibri" pitchFamily="34" charset="-122"/>
                 <a:cs typeface="Calibri" pitchFamily="34" charset="-120"/>
               </a:rPr>
-              <a:t>Watch Kafka UI</a:t>
-            </a:r>
-            <a:endParaRPr lang="en-US" sz="1350" dirty="0"/>
-          </a:p>
-        </p:txBody>
-      </p:sp>
-      <p:sp>
-        <p:nvSpPr>
-          <p:cNvPr id="17" name="Text 15"/>
-          <p:cNvSpPr txBox="1"/>
-          <p:nvPr/>
-        </p:nvSpPr>
-        <p:spPr>
-          <a:xfrm>
-            <a:off x="6903720" y="3941064"/>
-            <a:ext cx="4754880" cy="640080"/>
+              <a:t>Rider</a:t>
+            </a:r>
+            <a:endParaRPr lang="en-US" sz="1300" dirty="0"/>
+          </a:p>
+        </p:txBody>
+      </p:sp>
+      <p:sp>
+        <p:nvSpPr>
+          <p:cNvPr id="20" name="Text 18"/>
+          <p:cNvSpPr txBox="1"/>
+          <p:nvPr/>
+        </p:nvSpPr>
+        <p:spPr>
+          <a:xfrm>
+            <a:off x="7040880" y="4873752"/>
+            <a:ext cx="4297680" cy="640080"/>
           </a:xfrm>
           <a:prstGeom prst="rect">
             <a:avLst/>
@@ -8677,7 +9065,7 @@
               <a:buNone/>
             </a:pPr>
             <a:r>
-              <a:rPr lang="en-US" sz="1150" dirty="0">
+              <a:rPr lang="en-US" sz="1100" dirty="0">
                 <a:solidFill>
                   <a:srgbClr val="5B5B5B"/>
                 </a:solidFill>
@@ -8685,107 +9073,9 @@
                 <a:ea typeface="Calibri" pitchFamily="34" charset="-122"/>
                 <a:cs typeface="Calibri" pitchFamily="34" charset="-120"/>
               </a:rPr>
-              <a:t>http://localhost:8090 — topic and consumer-group offsets update live.</a:t>
-            </a:r>
-            <a:endParaRPr lang="en-US" sz="1150" dirty="0"/>
-          </a:p>
-        </p:txBody>
-      </p:sp>
-      <p:sp>
-        <p:nvSpPr>
-          <p:cNvPr id="18" name="Shape 16"/>
-          <p:cNvSpPr/>
-          <p:nvPr/>
-        </p:nvSpPr>
-        <p:spPr>
-          <a:xfrm>
-            <a:off x="6263640" y="4764024"/>
-            <a:ext cx="502920" cy="502920"/>
-          </a:xfrm>
-          <a:prstGeom prst="ellipse">
-            <a:avLst/>
-          </a:prstGeom>
-          <a:solidFill>
-            <a:srgbClr val="F96167"/>
-          </a:solidFill>
-          <a:ln/>
-        </p:spPr>
-      </p:sp>
-      <p:sp>
-        <p:nvSpPr>
-          <p:cNvPr id="19" name="Text 17"/>
-          <p:cNvSpPr txBox="1"/>
-          <p:nvPr/>
-        </p:nvSpPr>
-        <p:spPr>
-          <a:xfrm>
-            <a:off x="6263640" y="4764024"/>
-            <a:ext cx="502920" cy="502920"/>
-          </a:xfrm>
-          <a:prstGeom prst="rect">
-            <a:avLst/>
-          </a:prstGeom>
-          <a:noFill/>
-          <a:ln/>
-        </p:spPr>
-        <p:txBody>
-          <a:bodyPr wrap="square" lIns="0" tIns="0" rIns="0" bIns="0" rtlCol="0" anchor="ctr"/>
-          <a:lstStyle/>
-          <a:p>
-            <a:pPr algn="ctr" indent="0" marL="0">
-              <a:buNone/>
-            </a:pPr>
-            <a:r>
-              <a:rPr lang="en-US" sz="1600" b="1" dirty="0">
-                <a:solidFill>
-                  <a:srgbClr val="FFFFFF"/>
-                </a:solidFill>
-                <a:latin typeface="Calibri" pitchFamily="34" charset="0"/>
-                <a:ea typeface="Calibri" pitchFamily="34" charset="-122"/>
-                <a:cs typeface="Calibri" pitchFamily="34" charset="-120"/>
-              </a:rPr>
-              <a:t>4</a:t>
-            </a:r>
-            <a:endParaRPr lang="en-US" sz="1600" dirty="0"/>
-          </a:p>
-        </p:txBody>
-      </p:sp>
-      <p:sp>
-        <p:nvSpPr>
-          <p:cNvPr id="20" name="Text 18"/>
-          <p:cNvSpPr txBox="1"/>
-          <p:nvPr/>
-        </p:nvSpPr>
-        <p:spPr>
-          <a:xfrm>
-            <a:off x="6903720" y="4718304"/>
-            <a:ext cx="4754880" cy="365760"/>
-          </a:xfrm>
-          <a:prstGeom prst="rect">
-            <a:avLst/>
-          </a:prstGeom>
-          <a:noFill/>
-          <a:ln/>
-        </p:spPr>
-        <p:txBody>
-          <a:bodyPr wrap="square" lIns="0" tIns="0" rIns="0" bIns="0" rtlCol="0" anchor="ctr"/>
-          <a:lstStyle/>
-          <a:p>
-            <a:pPr indent="0" marL="0">
-              <a:buNone/>
-            </a:pPr>
-            <a:r>
-              <a:rPr lang="en-US" sz="1350" b="1" dirty="0">
-                <a:solidFill>
-                  <a:srgbClr val="2F3C7E"/>
-                </a:solidFill>
-                <a:latin typeface="Calibri" pitchFamily="34" charset="0"/>
-                <a:ea typeface="Calibri" pitchFamily="34" charset="-122"/>
-                <a:cs typeface="Calibri" pitchFamily="34" charset="-120"/>
-              </a:rPr>
-              <a:t>Kill and restart a consumer</a:t>
-            </a:r>
-            <a:endParaRPr lang="en-US" sz="1350" dirty="0"/>
+              <a:t>Sign in on a third tab — accept the pickup, mark delivered.</a:t>
+            </a:r>
+            <a:endParaRPr lang="en-US" sz="1100" dirty="0"/>
           </a:p>
         </p:txBody>
       </p:sp>
@@ -8797,8 +9087,8 @@
         </p:nvSpPr>
         <p:spPr>
           <a:xfrm>
-            <a:off x="6903720" y="5056632"/>
-            <a:ext cx="4754880" cy="640080"/>
+            <a:off x="6400800" y="5623560"/>
+            <a:ext cx="4937760" cy="457200"/>
           </a:xfrm>
           <a:prstGeom prst="rect">
             <a:avLst/>
@@ -8817,7 +9107,7 @@
               <a:buNone/>
             </a:pPr>
             <a:r>
-              <a:rPr lang="en-US" sz="1150" dirty="0">
+              <a:rPr lang="en-US" sz="1050" i="1" dirty="0">
                 <a:solidFill>
                   <a:srgbClr val="5B5B5B"/>
                 </a:solidFill>
@@ -8825,9 +9115,9 @@
                 <a:ea typeface="Calibri" pitchFamily="34" charset="-122"/>
                 <a:cs typeface="Calibri" pitchFamily="34" charset="-120"/>
               </a:rPr>
-              <a:t>docker compose stop/start rider-service — prove no event is lost.</a:t>
-            </a:r>
-            <a:endParaRPr lang="en-US" sz="1150" dirty="0"/>
+              <a:t>All three tabs update live within 2 seconds of each other — and stay in sync with anything done via curl at the same time.</a:t>
+            </a:r>
+            <a:endParaRPr lang="en-US" sz="1050" dirty="0"/>
           </a:p>
         </p:txBody>
       </p:sp>
@@ -9038,7 +9328,7 @@
                 <a:ea typeface="Calibri" pitchFamily="34" charset="-122"/>
                 <a:cs typeface="Calibri" pitchFamily="34" charset="-120"/>
               </a:rPr>
-              <a:t>Order status updates reach the customer, rider, and notification services in real time — without any service calling another directly, and without losing an update if one service is briefly unavailable.</a:t>
+              <a:t>Order status updates reach the customer, restaurant, and rider apps in real time — without any of them calling each other directly, and without losing an update if one service is briefly unavailable.</a:t>
             </a:r>
             <a:endParaRPr lang="en-US" sz="1600" dirty="0"/>
           </a:p>
@@ -9077,7 +9367,7 @@
                 <a:ea typeface="Cambria" pitchFamily="34" charset="-122"/>
                 <a:cs typeface="Cambria" pitchFamily="34" charset="-120"/>
               </a:rPr>
-              <a:t>4</a:t>
+              <a:t>3</a:t>
             </a:r>
             <a:endParaRPr lang="en-US" sz="6000" dirty="0"/>
           </a:p>
@@ -9116,7 +9406,7 @@
                 <a:ea typeface="Calibri" pitchFamily="34" charset="-122"/>
                 <a:cs typeface="Calibri" pitchFamily="34" charset="-120"/>
               </a:rPr>
-              <a:t>microservices, one shared event log</a:t>
+              <a:t>role-based apps, one shared event log</a:t>
             </a:r>
             <a:endParaRPr lang="en-US" sz="1300" dirty="0"/>
           </a:p>
@@ -9194,7 +9484,7 @@
                 <a:ea typeface="Calibri" pitchFamily="34" charset="-122"/>
                 <a:cs typeface="Calibri" pitchFamily="34" charset="-120"/>
               </a:rPr>
-              <a:t>Kafka topic replaces N x M direct calls</a:t>
+              <a:t>Kafka topic replaces every direct call</a:t>
             </a:r>
             <a:endParaRPr lang="en-US" sz="1300" dirty="0"/>
           </a:p>
@@ -9272,7 +9562,7 @@
                 <a:ea typeface="Calibri" pitchFamily="34" charset="-122"/>
                 <a:cs typeface="Calibri" pitchFamily="34" charset="-120"/>
               </a:rPr>
-              <a:t>events lost when a consumer restarts</a:t>
+              <a:t>events lost when a service restarts</a:t>
             </a:r>
             <a:endParaRPr lang="en-US" sz="1300" dirty="0"/>
           </a:p>
@@ -9354,7 +9644,7 @@
                 <a:ea typeface="Calibri" pitchFamily="34" charset="-122"/>
                 <a:cs typeface="Calibri" pitchFamily="34" charset="-120"/>
               </a:rPr>
-              <a:t>full runnable source, diagrams, and the demo script are on GitHub.</a:t>
+              <a:t>full runnable source, diagrams, and the live web dashboard are on GitHub.</a:t>
             </a:r>
             <a:endParaRPr lang="en-US" sz="1450" dirty="0"/>
           </a:p>

</xml_diff>